<commit_message>
Add MLflow registry evidence to presentation
</commit_message>
<xml_diff>
--- a/presentation/predictive-maintenance-mlflow-lifecycle.pptx
+++ b/presentation/predictive-maintenance-mlflow-lifecycle.pptx
@@ -11969,7 +11969,7 @@
 </file>
 
 <file path=ppt/slides/slide7.xml><?xml version="1.0" encoding="utf-8"?>
-<p:sld xmlns:p="http://schemas.openxmlformats.org/presentationml/2006/main">
+<p:sld xmlns:a="http://schemas.openxmlformats.org/drawingml/2006/main" xmlns:ns2="http://schemas.microsoft.com/office/drawing/2014/main" xmlns:ns4="http://schemas.microsoft.com/office/powerpoint/2010/main" xmlns:p="http://schemas.openxmlformats.org/presentationml/2006/main" xmlns:r="http://schemas.openxmlformats.org/officeDocument/2006/relationships">
   <p:cSld>
     <p:spTree>
       <p:nvGrpSpPr>
@@ -11978,34 +11978,34 @@
         <p:nvPr/>
       </p:nvGrpSpPr>
       <p:grpSpPr>
-        <a:xfrm xmlns:a="http://schemas.openxmlformats.org/drawingml/2006/main"/>
+        <a:xfrm/>
       </p:grpSpPr>
       <p:sp>
         <p:nvSpPr>
           <p:cNvPr id="1" name="">
-            <a:extLst xmlns:a="http://schemas.openxmlformats.org/drawingml/2006/main">
-              <a:ext uri="{FF2B5EF4-FFF2-40B4-BE49-F238E27FC236}">
-                <a16:creationId xmlns:a16="http://schemas.microsoft.com/office/drawing/2014/main" id="{3898718A-621D-4DE9-A178-72A6C4394994}"/>
-              </a:ext>
-            </a:extLst>
-          </p:cNvPr>
-          <p:cNvSpPr>
-            <a:spLocks xmlns:a="http://schemas.openxmlformats.org/drawingml/2006/main" noGrp="1"/>
-          </p:cNvSpPr>
-          <p:nvPr/>
-        </p:nvSpPr>
-        <p:spPr>
-          <a:xfrm xmlns:a="http://schemas.openxmlformats.org/drawingml/2006/main">
+            <a:extLst>
+              <a:ext uri="{FF2B5EF4-FFF2-40B4-BE49-F238E27FC236}">
+                <ns2:creationId id="{3898718A-621D-4DE9-A178-72A6C4394994}"/>
+              </a:ext>
+            </a:extLst>
+          </p:cNvPr>
+          <p:cNvSpPr>
+            <a:spLocks noGrp="1"/>
+          </p:cNvSpPr>
+          <p:nvPr/>
+        </p:nvSpPr>
+        <p:spPr>
+          <a:xfrm>
             <a:off x="0" y="0"/>
             <a:ext cx="12192000" cy="6858000"/>
           </a:xfrm>
-          <a:prstGeom xmlns:a="http://schemas.openxmlformats.org/drawingml/2006/main" prst="rect">
-            <a:avLst/>
-          </a:prstGeom>
-          <a:solidFill xmlns:a="http://schemas.openxmlformats.org/drawingml/2006/main">
+          <a:prstGeom prst="rect">
+            <a:avLst/>
+          </a:prstGeom>
+          <a:solidFill>
             <a:srgbClr val="08111F"/>
           </a:solidFill>
-          <a:ln xmlns:a="http://schemas.openxmlformats.org/drawingml/2006/main" w="0">
+          <a:ln w="0">
             <a:solidFill>
               <a:srgbClr val="000000">
                 <a:alpha val="0"/>
@@ -12018,29 +12018,29 @@
       <p:sp>
         <p:nvSpPr>
           <p:cNvPr id="2" name="">
-            <a:extLst xmlns:a="http://schemas.openxmlformats.org/drawingml/2006/main">
-              <a:ext uri="{FF2B5EF4-FFF2-40B4-BE49-F238E27FC236}">
-                <a16:creationId xmlns:a16="http://schemas.microsoft.com/office/drawing/2014/main" id="{A5510CAD-87DE-4D29-8911-9A2EFB15208C}"/>
-              </a:ext>
-            </a:extLst>
-          </p:cNvPr>
-          <p:cNvSpPr>
-            <a:spLocks xmlns:a="http://schemas.openxmlformats.org/drawingml/2006/main" noGrp="1"/>
-          </p:cNvSpPr>
-          <p:nvPr/>
-        </p:nvSpPr>
-        <p:spPr>
-          <a:xfrm xmlns:a="http://schemas.openxmlformats.org/drawingml/2006/main">
+            <a:extLst>
+              <a:ext uri="{FF2B5EF4-FFF2-40B4-BE49-F238E27FC236}">
+                <ns2:creationId id="{A5510CAD-87DE-4D29-8911-9A2EFB15208C}"/>
+              </a:ext>
+            </a:extLst>
+          </p:cNvPr>
+          <p:cNvSpPr>
+            <a:spLocks noGrp="1"/>
+          </p:cNvSpPr>
+          <p:nvPr/>
+        </p:nvSpPr>
+        <p:spPr>
+          <a:xfrm>
             <a:off x="0" y="0"/>
             <a:ext cx="12192000" cy="133350"/>
           </a:xfrm>
-          <a:prstGeom xmlns:a="http://schemas.openxmlformats.org/drawingml/2006/main" prst="rect">
-            <a:avLst/>
-          </a:prstGeom>
-          <a:solidFill xmlns:a="http://schemas.openxmlformats.org/drawingml/2006/main">
+          <a:prstGeom prst="rect">
+            <a:avLst/>
+          </a:prstGeom>
+          <a:solidFill>
             <a:srgbClr val="4FC3F7"/>
           </a:solidFill>
-          <a:ln xmlns:a="http://schemas.openxmlformats.org/drawingml/2006/main" w="0">
+          <a:ln w="0">
             <a:solidFill>
               <a:srgbClr val="000000">
                 <a:alpha val="0"/>
@@ -12053,43 +12053,43 @@
       <p:sp>
         <p:nvSpPr>
           <p:cNvPr id="3" name="">
-            <a:extLst xmlns:a="http://schemas.openxmlformats.org/drawingml/2006/main">
-              <a:ext uri="{FF2B5EF4-FFF2-40B4-BE49-F238E27FC236}">
-                <a16:creationId xmlns:a16="http://schemas.microsoft.com/office/drawing/2014/main" id="{D4F73C6A-9FB4-456F-92ED-32216B313352}"/>
-              </a:ext>
-            </a:extLst>
-          </p:cNvPr>
-          <p:cNvSpPr>
-            <a:spLocks xmlns:a="http://schemas.openxmlformats.org/drawingml/2006/main" noGrp="1"/>
-          </p:cNvSpPr>
-          <p:nvPr/>
-        </p:nvSpPr>
-        <p:spPr>
-          <a:xfrm xmlns:a="http://schemas.openxmlformats.org/drawingml/2006/main">
+            <a:extLst>
+              <a:ext uri="{FF2B5EF4-FFF2-40B4-BE49-F238E27FC236}">
+                <ns2:creationId id="{D4F73C6A-9FB4-456F-92ED-32216B313352}"/>
+              </a:ext>
+            </a:extLst>
+          </p:cNvPr>
+          <p:cNvSpPr>
+            <a:spLocks noGrp="1"/>
+          </p:cNvSpPr>
+          <p:nvPr/>
+        </p:nvSpPr>
+        <p:spPr>
+          <a:xfrm>
             <a:off x="514350" y="266700"/>
             <a:ext cx="4953000" cy="209550"/>
           </a:xfrm>
-          <a:prstGeom xmlns:a="http://schemas.openxmlformats.org/drawingml/2006/main" prst="rect">
-            <a:avLst/>
-          </a:prstGeom>
-          <a:solidFill xmlns:a="http://schemas.openxmlformats.org/drawingml/2006/main">
+          <a:prstGeom prst="rect">
+            <a:avLst/>
+          </a:prstGeom>
+          <a:solidFill>
             <a:srgbClr val="000000">
               <a:alpha val="0"/>
             </a:srgbClr>
           </a:solidFill>
-          <a:ln xmlns:a="http://schemas.openxmlformats.org/drawingml/2006/main" w="0">
-            <a:solidFill>
-              <a:srgbClr val="000000">
-                <a:alpha val="0"/>
-              </a:srgbClr>
-            </a:solidFill>
-            <a:prstDash val="solid"/>
-          </a:ln>
-        </p:spPr>
-        <p:txBody>
-          <a:bodyPr xmlns:a="http://schemas.openxmlformats.org/drawingml/2006/main" lIns="0" tIns="0" rIns="0" bIns="0" anchor="t"/>
-          <a:lstStyle xmlns:a="http://schemas.openxmlformats.org/drawingml/2006/main"/>
-          <a:p xmlns:a="http://schemas.openxmlformats.org/drawingml/2006/main">
+          <a:ln w="0">
+            <a:solidFill>
+              <a:srgbClr val="000000">
+                <a:alpha val="0"/>
+              </a:srgbClr>
+            </a:solidFill>
+            <a:prstDash val="solid"/>
+          </a:ln>
+        </p:spPr>
+        <p:txBody>
+          <a:bodyPr lIns="0" tIns="0" rIns="0" bIns="0" anchor="t"/>
+          <a:lstStyle/>
+          <a:p>
             <a:pPr algn="l">
               <a:defRPr sz="975" b="1">
                 <a:solidFill>
@@ -12117,43 +12117,43 @@
       <p:sp>
         <p:nvSpPr>
           <p:cNvPr id="4" name="">
-            <a:extLst xmlns:a="http://schemas.openxmlformats.org/drawingml/2006/main">
-              <a:ext uri="{FF2B5EF4-FFF2-40B4-BE49-F238E27FC236}">
-                <a16:creationId xmlns:a16="http://schemas.microsoft.com/office/drawing/2014/main" id="{DE395EDA-F7CC-4C90-B21C-CBDF792CAF0A}"/>
-              </a:ext>
-            </a:extLst>
-          </p:cNvPr>
-          <p:cNvSpPr>
-            <a:spLocks xmlns:a="http://schemas.openxmlformats.org/drawingml/2006/main" noGrp="1"/>
-          </p:cNvSpPr>
-          <p:nvPr/>
-        </p:nvSpPr>
-        <p:spPr>
-          <a:xfrm xmlns:a="http://schemas.openxmlformats.org/drawingml/2006/main">
+            <a:extLst>
+              <a:ext uri="{FF2B5EF4-FFF2-40B4-BE49-F238E27FC236}">
+                <ns2:creationId id="{DE395EDA-F7CC-4C90-B21C-CBDF792CAF0A}"/>
+              </a:ext>
+            </a:extLst>
+          </p:cNvPr>
+          <p:cNvSpPr>
+            <a:spLocks noGrp="1"/>
+          </p:cNvSpPr>
+          <p:nvPr/>
+        </p:nvSpPr>
+        <p:spPr>
+          <a:xfrm>
             <a:off x="514350" y="552450"/>
             <a:ext cx="7239000" cy="704850"/>
           </a:xfrm>
-          <a:prstGeom xmlns:a="http://schemas.openxmlformats.org/drawingml/2006/main" prst="rect">
-            <a:avLst/>
-          </a:prstGeom>
-          <a:solidFill xmlns:a="http://schemas.openxmlformats.org/drawingml/2006/main">
+          <a:prstGeom prst="rect">
+            <a:avLst/>
+          </a:prstGeom>
+          <a:solidFill>
             <a:srgbClr val="000000">
               <a:alpha val="0"/>
             </a:srgbClr>
           </a:solidFill>
-          <a:ln xmlns:a="http://schemas.openxmlformats.org/drawingml/2006/main" w="0">
-            <a:solidFill>
-              <a:srgbClr val="000000">
-                <a:alpha val="0"/>
-              </a:srgbClr>
-            </a:solidFill>
-            <a:prstDash val="solid"/>
-          </a:ln>
-        </p:spPr>
-        <p:txBody>
-          <a:bodyPr xmlns:a="http://schemas.openxmlformats.org/drawingml/2006/main" lIns="0" tIns="0" rIns="0" bIns="0" anchor="t"/>
-          <a:lstStyle xmlns:a="http://schemas.openxmlformats.org/drawingml/2006/main"/>
-          <a:p xmlns:a="http://schemas.openxmlformats.org/drawingml/2006/main">
+          <a:ln w="0">
+            <a:solidFill>
+              <a:srgbClr val="000000">
+                <a:alpha val="0"/>
+              </a:srgbClr>
+            </a:solidFill>
+            <a:prstDash val="solid"/>
+          </a:ln>
+        </p:spPr>
+        <p:txBody>
+          <a:bodyPr lIns="0" tIns="0" rIns="0" bIns="0" anchor="t"/>
+          <a:lstStyle/>
+          <a:p>
             <a:pPr algn="l">
               <a:defRPr sz="2400" b="1">
                 <a:solidFill>
@@ -12181,43 +12181,43 @@
       <p:sp>
         <p:nvSpPr>
           <p:cNvPr id="5" name="">
-            <a:extLst xmlns:a="http://schemas.openxmlformats.org/drawingml/2006/main">
-              <a:ext uri="{FF2B5EF4-FFF2-40B4-BE49-F238E27FC236}">
-                <a16:creationId xmlns:a16="http://schemas.microsoft.com/office/drawing/2014/main" id="{52495AC9-F118-4E7C-978C-B1E437AF69A0}"/>
-              </a:ext>
-            </a:extLst>
-          </p:cNvPr>
-          <p:cNvSpPr>
-            <a:spLocks xmlns:a="http://schemas.openxmlformats.org/drawingml/2006/main" noGrp="1"/>
-          </p:cNvSpPr>
-          <p:nvPr/>
-        </p:nvSpPr>
-        <p:spPr>
-          <a:xfrm xmlns:a="http://schemas.openxmlformats.org/drawingml/2006/main">
+            <a:extLst>
+              <a:ext uri="{FF2B5EF4-FFF2-40B4-BE49-F238E27FC236}">
+                <ns2:creationId id="{52495AC9-F118-4E7C-978C-B1E437AF69A0}"/>
+              </a:ext>
+            </a:extLst>
+          </p:cNvPr>
+          <p:cNvSpPr>
+            <a:spLocks noGrp="1"/>
+          </p:cNvSpPr>
+          <p:nvPr/>
+        </p:nvSpPr>
+        <p:spPr>
+          <a:xfrm>
             <a:off x="533400" y="1219200"/>
             <a:ext cx="7239000" cy="304800"/>
           </a:xfrm>
-          <a:prstGeom xmlns:a="http://schemas.openxmlformats.org/drawingml/2006/main" prst="rect">
-            <a:avLst/>
-          </a:prstGeom>
-          <a:solidFill xmlns:a="http://schemas.openxmlformats.org/drawingml/2006/main">
+          <a:prstGeom prst="rect">
+            <a:avLst/>
+          </a:prstGeom>
+          <a:solidFill>
             <a:srgbClr val="000000">
               <a:alpha val="0"/>
             </a:srgbClr>
           </a:solidFill>
-          <a:ln xmlns:a="http://schemas.openxmlformats.org/drawingml/2006/main" w="0">
-            <a:solidFill>
-              <a:srgbClr val="000000">
-                <a:alpha val="0"/>
-              </a:srgbClr>
-            </a:solidFill>
-            <a:prstDash val="solid"/>
-          </a:ln>
-        </p:spPr>
-        <p:txBody>
-          <a:bodyPr xmlns:a="http://schemas.openxmlformats.org/drawingml/2006/main" lIns="0" tIns="0" rIns="0" bIns="0" anchor="t"/>
-          <a:lstStyle xmlns:a="http://schemas.openxmlformats.org/drawingml/2006/main"/>
-          <a:p xmlns:a="http://schemas.openxmlformats.org/drawingml/2006/main">
+          <a:ln w="0">
+            <a:solidFill>
+              <a:srgbClr val="000000">
+                <a:alpha val="0"/>
+              </a:srgbClr>
+            </a:solidFill>
+            <a:prstDash val="solid"/>
+          </a:ln>
+        </p:spPr>
+        <p:txBody>
+          <a:bodyPr lIns="0" tIns="0" rIns="0" bIns="0" anchor="t"/>
+          <a:lstStyle/>
+          <a:p>
             <a:pPr algn="l">
               <a:defRPr sz="1200" b="0">
                 <a:solidFill>
@@ -12246,20 +12246,20 @@
         <p:nvPicPr>
           <p:cNvPr id="6" name=""/>
           <p:cNvPicPr>
-            <a:picLocks xmlns:a="http://schemas.openxmlformats.org/drawingml/2006/main" noChangeAspect="1"/>
+            <a:picLocks noChangeAspect="1"/>
           </p:cNvPicPr>
           <p:nvPr/>
         </p:nvPicPr>
         <p:blipFill>
-          <a:blip xmlns:r="http://schemas.openxmlformats.org/officeDocument/2006/relationships" xmlns:a="http://schemas.openxmlformats.org/drawingml/2006/main" r:embed="Rfbd1272d50284f9e"/>
-          <a:stretch xmlns:a="http://schemas.openxmlformats.org/drawingml/2006/main"/>
+          <a:blip r:embed="Rfbd1272d50284f9e"/>
+          <a:stretch/>
         </p:blipFill>
         <p:spPr>
-          <a:xfrm xmlns:a="http://schemas.openxmlformats.org/drawingml/2006/main">
-            <a:off x="666750" y="1468240"/>
-            <a:ext cx="3095625" cy="2721370"/>
-          </a:xfrm>
-          <a:prstGeom xmlns:a="http://schemas.openxmlformats.org/drawingml/2006/main" prst="rect">
+          <a:xfrm>
+            <a:off x="666750" y="1504950"/>
+            <a:ext cx="3095625" cy="2149740"/>
+          </a:xfrm>
+          <a:prstGeom prst="rect">
             <a:avLst/>
           </a:prstGeom>
         </p:spPr>
@@ -12268,20 +12268,20 @@
         <p:nvPicPr>
           <p:cNvPr id="7" name=""/>
           <p:cNvPicPr>
-            <a:picLocks xmlns:a="http://schemas.openxmlformats.org/drawingml/2006/main" noChangeAspect="1"/>
+            <a:picLocks noChangeAspect="1"/>
           </p:cNvPicPr>
           <p:nvPr/>
         </p:nvPicPr>
         <p:blipFill>
-          <a:blip xmlns:r="http://schemas.openxmlformats.org/officeDocument/2006/relationships" xmlns:a="http://schemas.openxmlformats.org/drawingml/2006/main" r:embed="R8bc922080e8c483a"/>
-          <a:stretch xmlns:a="http://schemas.openxmlformats.org/drawingml/2006/main"/>
+          <a:blip r:embed="R8bc922080e8c483a"/>
+          <a:stretch/>
         </p:blipFill>
         <p:spPr>
-          <a:xfrm xmlns:a="http://schemas.openxmlformats.org/drawingml/2006/main">
-            <a:off x="4041716" y="1352550"/>
-            <a:ext cx="2917944" cy="2952750"/>
-          </a:xfrm>
-          <a:prstGeom xmlns:a="http://schemas.openxmlformats.org/drawingml/2006/main" prst="rect">
+          <a:xfrm>
+            <a:off x="4057650" y="1504950"/>
+            <a:ext cx="3095625" cy="2149740"/>
+          </a:xfrm>
+          <a:prstGeom prst="rect">
             <a:avLst/>
           </a:prstGeom>
         </p:spPr>
@@ -12289,29 +12289,29 @@
       <p:sp>
         <p:nvSpPr>
           <p:cNvPr id="8" name="">
-            <a:extLst xmlns:a="http://schemas.openxmlformats.org/drawingml/2006/main">
-              <a:ext uri="{FF2B5EF4-FFF2-40B4-BE49-F238E27FC236}">
-                <a16:creationId xmlns:a16="http://schemas.microsoft.com/office/drawing/2014/main" id="{91AB58D0-E61A-4CA9-A6C7-CC700741A377}"/>
-              </a:ext>
-            </a:extLst>
-          </p:cNvPr>
-          <p:cNvSpPr>
-            <a:spLocks xmlns:a="http://schemas.openxmlformats.org/drawingml/2006/main" noGrp="1"/>
-          </p:cNvSpPr>
-          <p:nvPr/>
-        </p:nvSpPr>
-        <p:spPr>
-          <a:xfrm xmlns:a="http://schemas.openxmlformats.org/drawingml/2006/main">
+            <a:extLst>
+              <a:ext uri="{FF2B5EF4-FFF2-40B4-BE49-F238E27FC236}">
+                <ns2:creationId id="{91AB58D0-E61A-4CA9-A6C7-CC700741A377}"/>
+              </a:ext>
+            </a:extLst>
+          </p:cNvPr>
+          <p:cNvSpPr>
+            <a:spLocks noGrp="1"/>
+          </p:cNvSpPr>
+          <p:nvPr/>
+        </p:nvSpPr>
+        <p:spPr>
+          <a:xfrm>
             <a:off x="7429500" y="1447800"/>
             <a:ext cx="3429000" cy="742950"/>
           </a:xfrm>
-          <a:prstGeom xmlns:a="http://schemas.openxmlformats.org/drawingml/2006/main" prst="rect">
-            <a:avLst/>
-          </a:prstGeom>
-          <a:solidFill xmlns:a="http://schemas.openxmlformats.org/drawingml/2006/main">
+          <a:prstGeom prst="rect">
+            <a:avLst/>
+          </a:prstGeom>
+          <a:solidFill>
             <a:srgbClr val="10243A"/>
           </a:solidFill>
-          <a:ln xmlns:a="http://schemas.openxmlformats.org/drawingml/2006/main" w="9525">
+          <a:ln w="9525">
             <a:solidFill>
               <a:srgbClr val="24435F"/>
             </a:solidFill>
@@ -12322,43 +12322,43 @@
       <p:sp>
         <p:nvSpPr>
           <p:cNvPr id="9" name="">
-            <a:extLst xmlns:a="http://schemas.openxmlformats.org/drawingml/2006/main">
-              <a:ext uri="{FF2B5EF4-FFF2-40B4-BE49-F238E27FC236}">
-                <a16:creationId xmlns:a16="http://schemas.microsoft.com/office/drawing/2014/main" id="{BFF95BB3-943E-46AC-9C64-B5181FCC56D8}"/>
-              </a:ext>
-            </a:extLst>
-          </p:cNvPr>
-          <p:cNvSpPr>
-            <a:spLocks xmlns:a="http://schemas.openxmlformats.org/drawingml/2006/main" noGrp="1"/>
-          </p:cNvSpPr>
-          <p:nvPr/>
-        </p:nvSpPr>
-        <p:spPr>
-          <a:xfrm xmlns:a="http://schemas.openxmlformats.org/drawingml/2006/main">
+            <a:extLst>
+              <a:ext uri="{FF2B5EF4-FFF2-40B4-BE49-F238E27FC236}">
+                <ns2:creationId id="{BFF95BB3-943E-46AC-9C64-B5181FCC56D8}"/>
+              </a:ext>
+            </a:extLst>
+          </p:cNvPr>
+          <p:cNvSpPr>
+            <a:spLocks noGrp="1"/>
+          </p:cNvSpPr>
+          <p:nvPr/>
+        </p:nvSpPr>
+        <p:spPr>
+          <a:xfrm>
             <a:off x="7581900" y="1581150"/>
             <a:ext cx="3124200" cy="323850"/>
           </a:xfrm>
-          <a:prstGeom xmlns:a="http://schemas.openxmlformats.org/drawingml/2006/main" prst="rect">
-            <a:avLst/>
-          </a:prstGeom>
-          <a:solidFill xmlns:a="http://schemas.openxmlformats.org/drawingml/2006/main">
+          <a:prstGeom prst="rect">
+            <a:avLst/>
+          </a:prstGeom>
+          <a:solidFill>
             <a:srgbClr val="000000">
               <a:alpha val="0"/>
             </a:srgbClr>
           </a:solidFill>
-          <a:ln xmlns:a="http://schemas.openxmlformats.org/drawingml/2006/main" w="0">
-            <a:solidFill>
-              <a:srgbClr val="000000">
-                <a:alpha val="0"/>
-              </a:srgbClr>
-            </a:solidFill>
-            <a:prstDash val="solid"/>
-          </a:ln>
-        </p:spPr>
-        <p:txBody>
-          <a:bodyPr xmlns:a="http://schemas.openxmlformats.org/drawingml/2006/main" lIns="0" tIns="0" rIns="0" bIns="0" anchor="t"/>
-          <a:lstStyle xmlns:a="http://schemas.openxmlformats.org/drawingml/2006/main"/>
-          <a:p xmlns:a="http://schemas.openxmlformats.org/drawingml/2006/main">
+          <a:ln w="0">
+            <a:solidFill>
+              <a:srgbClr val="000000">
+                <a:alpha val="0"/>
+              </a:srgbClr>
+            </a:solidFill>
+            <a:prstDash val="solid"/>
+          </a:ln>
+        </p:spPr>
+        <p:txBody>
+          <a:bodyPr lIns="0" tIns="0" rIns="0" bIns="0" anchor="t"/>
+          <a:lstStyle/>
+          <a:p>
             <a:pPr algn="l">
               <a:defRPr sz="1800" b="1">
                 <a:solidFill>
@@ -12386,43 +12386,43 @@
       <p:sp>
         <p:nvSpPr>
           <p:cNvPr id="10" name="">
-            <a:extLst xmlns:a="http://schemas.openxmlformats.org/drawingml/2006/main">
-              <a:ext uri="{FF2B5EF4-FFF2-40B4-BE49-F238E27FC236}">
-                <a16:creationId xmlns:a16="http://schemas.microsoft.com/office/drawing/2014/main" id="{3C494E06-0B8C-4288-8FBA-2F0235D3EDF2}"/>
-              </a:ext>
-            </a:extLst>
-          </p:cNvPr>
-          <p:cNvSpPr>
-            <a:spLocks xmlns:a="http://schemas.openxmlformats.org/drawingml/2006/main" noGrp="1"/>
-          </p:cNvSpPr>
-          <p:nvPr/>
-        </p:nvSpPr>
-        <p:spPr>
-          <a:xfrm xmlns:a="http://schemas.openxmlformats.org/drawingml/2006/main">
+            <a:extLst>
+              <a:ext uri="{FF2B5EF4-FFF2-40B4-BE49-F238E27FC236}">
+                <ns2:creationId id="{3C494E06-0B8C-4288-8FBA-2F0235D3EDF2}"/>
+              </a:ext>
+            </a:extLst>
+          </p:cNvPr>
+          <p:cNvSpPr>
+            <a:spLocks noGrp="1"/>
+          </p:cNvSpPr>
+          <p:nvPr/>
+        </p:nvSpPr>
+        <p:spPr>
+          <a:xfrm>
             <a:off x="7581900" y="1943100"/>
             <a:ext cx="3124200" cy="342900"/>
           </a:xfrm>
-          <a:prstGeom xmlns:a="http://schemas.openxmlformats.org/drawingml/2006/main" prst="rect">
-            <a:avLst/>
-          </a:prstGeom>
-          <a:solidFill xmlns:a="http://schemas.openxmlformats.org/drawingml/2006/main">
+          <a:prstGeom prst="rect">
+            <a:avLst/>
+          </a:prstGeom>
+          <a:solidFill>
             <a:srgbClr val="000000">
               <a:alpha val="0"/>
             </a:srgbClr>
           </a:solidFill>
-          <a:ln xmlns:a="http://schemas.openxmlformats.org/drawingml/2006/main" w="0">
-            <a:solidFill>
-              <a:srgbClr val="000000">
-                <a:alpha val="0"/>
-              </a:srgbClr>
-            </a:solidFill>
-            <a:prstDash val="solid"/>
-          </a:ln>
-        </p:spPr>
-        <p:txBody>
-          <a:bodyPr xmlns:a="http://schemas.openxmlformats.org/drawingml/2006/main" lIns="0" tIns="0" rIns="0" bIns="0" anchor="t"/>
-          <a:lstStyle xmlns:a="http://schemas.openxmlformats.org/drawingml/2006/main"/>
-          <a:p xmlns:a="http://schemas.openxmlformats.org/drawingml/2006/main">
+          <a:ln w="0">
+            <a:solidFill>
+              <a:srgbClr val="000000">
+                <a:alpha val="0"/>
+              </a:srgbClr>
+            </a:solidFill>
+            <a:prstDash val="solid"/>
+          </a:ln>
+        </p:spPr>
+        <p:txBody>
+          <a:bodyPr lIns="0" tIns="0" rIns="0" bIns="0" anchor="t"/>
+          <a:lstStyle/>
+          <a:p>
             <a:pPr algn="l">
               <a:defRPr sz="900" b="0">
                 <a:solidFill>
@@ -12450,29 +12450,29 @@
       <p:sp>
         <p:nvSpPr>
           <p:cNvPr id="11" name="">
-            <a:extLst xmlns:a="http://schemas.openxmlformats.org/drawingml/2006/main">
-              <a:ext uri="{FF2B5EF4-FFF2-40B4-BE49-F238E27FC236}">
-                <a16:creationId xmlns:a16="http://schemas.microsoft.com/office/drawing/2014/main" id="{D67510A6-2986-4ADA-8071-C5CCD1EE44F9}"/>
-              </a:ext>
-            </a:extLst>
-          </p:cNvPr>
-          <p:cNvSpPr>
-            <a:spLocks xmlns:a="http://schemas.openxmlformats.org/drawingml/2006/main" noGrp="1"/>
-          </p:cNvSpPr>
-          <p:nvPr/>
-        </p:nvSpPr>
-        <p:spPr>
-          <a:xfrm xmlns:a="http://schemas.openxmlformats.org/drawingml/2006/main">
+            <a:extLst>
+              <a:ext uri="{FF2B5EF4-FFF2-40B4-BE49-F238E27FC236}">
+                <ns2:creationId id="{D67510A6-2986-4ADA-8071-C5CCD1EE44F9}"/>
+              </a:ext>
+            </a:extLst>
+          </p:cNvPr>
+          <p:cNvSpPr>
+            <a:spLocks noGrp="1"/>
+          </p:cNvSpPr>
+          <p:nvPr/>
+        </p:nvSpPr>
+        <p:spPr>
+          <a:xfrm>
             <a:off x="7429500" y="2362200"/>
             <a:ext cx="1428750" cy="742950"/>
           </a:xfrm>
-          <a:prstGeom xmlns:a="http://schemas.openxmlformats.org/drawingml/2006/main" prst="rect">
-            <a:avLst/>
-          </a:prstGeom>
-          <a:solidFill xmlns:a="http://schemas.openxmlformats.org/drawingml/2006/main">
+          <a:prstGeom prst="rect">
+            <a:avLst/>
+          </a:prstGeom>
+          <a:solidFill>
             <a:srgbClr val="10243A"/>
           </a:solidFill>
-          <a:ln xmlns:a="http://schemas.openxmlformats.org/drawingml/2006/main" w="9525">
+          <a:ln w="9525">
             <a:solidFill>
               <a:srgbClr val="24435F"/>
             </a:solidFill>
@@ -12483,43 +12483,43 @@
       <p:sp>
         <p:nvSpPr>
           <p:cNvPr id="12" name="">
-            <a:extLst xmlns:a="http://schemas.openxmlformats.org/drawingml/2006/main">
-              <a:ext uri="{FF2B5EF4-FFF2-40B4-BE49-F238E27FC236}">
-                <a16:creationId xmlns:a16="http://schemas.microsoft.com/office/drawing/2014/main" id="{EAC55252-47CA-4E9C-9E2F-74B64251EE98}"/>
-              </a:ext>
-            </a:extLst>
-          </p:cNvPr>
-          <p:cNvSpPr>
-            <a:spLocks xmlns:a="http://schemas.openxmlformats.org/drawingml/2006/main" noGrp="1"/>
-          </p:cNvSpPr>
-          <p:nvPr/>
-        </p:nvSpPr>
-        <p:spPr>
-          <a:xfrm xmlns:a="http://schemas.openxmlformats.org/drawingml/2006/main">
+            <a:extLst>
+              <a:ext uri="{FF2B5EF4-FFF2-40B4-BE49-F238E27FC236}">
+                <ns2:creationId id="{EAC55252-47CA-4E9C-9E2F-74B64251EE98}"/>
+              </a:ext>
+            </a:extLst>
+          </p:cNvPr>
+          <p:cNvSpPr>
+            <a:spLocks noGrp="1"/>
+          </p:cNvSpPr>
+          <p:nvPr/>
+        </p:nvSpPr>
+        <p:spPr>
+          <a:xfrm>
             <a:off x="7581900" y="2495550"/>
             <a:ext cx="1123950" cy="323850"/>
           </a:xfrm>
-          <a:prstGeom xmlns:a="http://schemas.openxmlformats.org/drawingml/2006/main" prst="rect">
-            <a:avLst/>
-          </a:prstGeom>
-          <a:solidFill xmlns:a="http://schemas.openxmlformats.org/drawingml/2006/main">
+          <a:prstGeom prst="rect">
+            <a:avLst/>
+          </a:prstGeom>
+          <a:solidFill>
             <a:srgbClr val="000000">
               <a:alpha val="0"/>
             </a:srgbClr>
           </a:solidFill>
-          <a:ln xmlns:a="http://schemas.openxmlformats.org/drawingml/2006/main" w="0">
-            <a:solidFill>
-              <a:srgbClr val="000000">
-                <a:alpha val="0"/>
-              </a:srgbClr>
-            </a:solidFill>
-            <a:prstDash val="solid"/>
-          </a:ln>
-        </p:spPr>
-        <p:txBody>
-          <a:bodyPr xmlns:a="http://schemas.openxmlformats.org/drawingml/2006/main" lIns="0" tIns="0" rIns="0" bIns="0" anchor="t"/>
-          <a:lstStyle xmlns:a="http://schemas.openxmlformats.org/drawingml/2006/main"/>
-          <a:p xmlns:a="http://schemas.openxmlformats.org/drawingml/2006/main">
+          <a:ln w="0">
+            <a:solidFill>
+              <a:srgbClr val="000000">
+                <a:alpha val="0"/>
+              </a:srgbClr>
+            </a:solidFill>
+            <a:prstDash val="solid"/>
+          </a:ln>
+        </p:spPr>
+        <p:txBody>
+          <a:bodyPr lIns="0" tIns="0" rIns="0" bIns="0" anchor="t"/>
+          <a:lstStyle/>
+          <a:p>
             <a:pPr algn="l">
               <a:defRPr sz="1800" b="1">
                 <a:solidFill>
@@ -12547,43 +12547,43 @@
       <p:sp>
         <p:nvSpPr>
           <p:cNvPr id="13" name="">
-            <a:extLst xmlns:a="http://schemas.openxmlformats.org/drawingml/2006/main">
-              <a:ext uri="{FF2B5EF4-FFF2-40B4-BE49-F238E27FC236}">
-                <a16:creationId xmlns:a16="http://schemas.microsoft.com/office/drawing/2014/main" id="{FCCD44C2-4BE1-49F0-92B9-FD7F9471DBAD}"/>
-              </a:ext>
-            </a:extLst>
-          </p:cNvPr>
-          <p:cNvSpPr>
-            <a:spLocks xmlns:a="http://schemas.openxmlformats.org/drawingml/2006/main" noGrp="1"/>
-          </p:cNvSpPr>
-          <p:nvPr/>
-        </p:nvSpPr>
-        <p:spPr>
-          <a:xfrm xmlns:a="http://schemas.openxmlformats.org/drawingml/2006/main">
+            <a:extLst>
+              <a:ext uri="{FF2B5EF4-FFF2-40B4-BE49-F238E27FC236}">
+                <ns2:creationId id="{FCCD44C2-4BE1-49F0-92B9-FD7F9471DBAD}"/>
+              </a:ext>
+            </a:extLst>
+          </p:cNvPr>
+          <p:cNvSpPr>
+            <a:spLocks noGrp="1"/>
+          </p:cNvSpPr>
+          <p:nvPr/>
+        </p:nvSpPr>
+        <p:spPr>
+          <a:xfrm>
             <a:off x="7581900" y="2857500"/>
             <a:ext cx="1123950" cy="342900"/>
           </a:xfrm>
-          <a:prstGeom xmlns:a="http://schemas.openxmlformats.org/drawingml/2006/main" prst="rect">
-            <a:avLst/>
-          </a:prstGeom>
-          <a:solidFill xmlns:a="http://schemas.openxmlformats.org/drawingml/2006/main">
+          <a:prstGeom prst="rect">
+            <a:avLst/>
+          </a:prstGeom>
+          <a:solidFill>
             <a:srgbClr val="000000">
               <a:alpha val="0"/>
             </a:srgbClr>
           </a:solidFill>
-          <a:ln xmlns:a="http://schemas.openxmlformats.org/drawingml/2006/main" w="0">
-            <a:solidFill>
-              <a:srgbClr val="000000">
-                <a:alpha val="0"/>
-              </a:srgbClr>
-            </a:solidFill>
-            <a:prstDash val="solid"/>
-          </a:ln>
-        </p:spPr>
-        <p:txBody>
-          <a:bodyPr xmlns:a="http://schemas.openxmlformats.org/drawingml/2006/main" lIns="0" tIns="0" rIns="0" bIns="0" anchor="t"/>
-          <a:lstStyle xmlns:a="http://schemas.openxmlformats.org/drawingml/2006/main"/>
-          <a:p xmlns:a="http://schemas.openxmlformats.org/drawingml/2006/main">
+          <a:ln w="0">
+            <a:solidFill>
+              <a:srgbClr val="000000">
+                <a:alpha val="0"/>
+              </a:srgbClr>
+            </a:solidFill>
+            <a:prstDash val="solid"/>
+          </a:ln>
+        </p:spPr>
+        <p:txBody>
+          <a:bodyPr lIns="0" tIns="0" rIns="0" bIns="0" anchor="t"/>
+          <a:lstStyle/>
+          <a:p>
             <a:pPr algn="l">
               <a:defRPr sz="900" b="0">
                 <a:solidFill>
@@ -12611,29 +12611,29 @@
       <p:sp>
         <p:nvSpPr>
           <p:cNvPr id="14" name="">
-            <a:extLst xmlns:a="http://schemas.openxmlformats.org/drawingml/2006/main">
-              <a:ext uri="{FF2B5EF4-FFF2-40B4-BE49-F238E27FC236}">
-                <a16:creationId xmlns:a16="http://schemas.microsoft.com/office/drawing/2014/main" id="{0E972CD0-8A71-4584-ADE7-79030F63DEB8}"/>
-              </a:ext>
-            </a:extLst>
-          </p:cNvPr>
-          <p:cNvSpPr>
-            <a:spLocks xmlns:a="http://schemas.openxmlformats.org/drawingml/2006/main" noGrp="1"/>
-          </p:cNvSpPr>
-          <p:nvPr/>
-        </p:nvSpPr>
-        <p:spPr>
-          <a:xfrm xmlns:a="http://schemas.openxmlformats.org/drawingml/2006/main">
+            <a:extLst>
+              <a:ext uri="{FF2B5EF4-FFF2-40B4-BE49-F238E27FC236}">
+                <ns2:creationId id="{0E972CD0-8A71-4584-ADE7-79030F63DEB8}"/>
+              </a:ext>
+            </a:extLst>
+          </p:cNvPr>
+          <p:cNvSpPr>
+            <a:spLocks noGrp="1"/>
+          </p:cNvSpPr>
+          <p:nvPr/>
+        </p:nvSpPr>
+        <p:spPr>
+          <a:xfrm>
             <a:off x="9048750" y="2362200"/>
             <a:ext cx="2190750" cy="742950"/>
           </a:xfrm>
-          <a:prstGeom xmlns:a="http://schemas.openxmlformats.org/drawingml/2006/main" prst="rect">
-            <a:avLst/>
-          </a:prstGeom>
-          <a:solidFill xmlns:a="http://schemas.openxmlformats.org/drawingml/2006/main">
+          <a:prstGeom prst="rect">
+            <a:avLst/>
+          </a:prstGeom>
+          <a:solidFill>
             <a:srgbClr val="10243A"/>
           </a:solidFill>
-          <a:ln xmlns:a="http://schemas.openxmlformats.org/drawingml/2006/main" w="9525">
+          <a:ln w="9525">
             <a:solidFill>
               <a:srgbClr val="24435F"/>
             </a:solidFill>
@@ -12644,43 +12644,43 @@
       <p:sp>
         <p:nvSpPr>
           <p:cNvPr id="15" name="">
-            <a:extLst xmlns:a="http://schemas.openxmlformats.org/drawingml/2006/main">
-              <a:ext uri="{FF2B5EF4-FFF2-40B4-BE49-F238E27FC236}">
-                <a16:creationId xmlns:a16="http://schemas.microsoft.com/office/drawing/2014/main" id="{8FBB88EF-206F-4D9A-9037-64FE62E37E4F}"/>
-              </a:ext>
-            </a:extLst>
-          </p:cNvPr>
-          <p:cNvSpPr>
-            <a:spLocks xmlns:a="http://schemas.openxmlformats.org/drawingml/2006/main" noGrp="1"/>
-          </p:cNvSpPr>
-          <p:nvPr/>
-        </p:nvSpPr>
-        <p:spPr>
-          <a:xfrm xmlns:a="http://schemas.openxmlformats.org/drawingml/2006/main">
+            <a:extLst>
+              <a:ext uri="{FF2B5EF4-FFF2-40B4-BE49-F238E27FC236}">
+                <ns2:creationId id="{8FBB88EF-206F-4D9A-9037-64FE62E37E4F}"/>
+              </a:ext>
+            </a:extLst>
+          </p:cNvPr>
+          <p:cNvSpPr>
+            <a:spLocks noGrp="1"/>
+          </p:cNvSpPr>
+          <p:nvPr/>
+        </p:nvSpPr>
+        <p:spPr>
+          <a:xfrm>
             <a:off x="9201150" y="2495550"/>
             <a:ext cx="1885950" cy="323850"/>
           </a:xfrm>
-          <a:prstGeom xmlns:a="http://schemas.openxmlformats.org/drawingml/2006/main" prst="rect">
-            <a:avLst/>
-          </a:prstGeom>
-          <a:solidFill xmlns:a="http://schemas.openxmlformats.org/drawingml/2006/main">
+          <a:prstGeom prst="rect">
+            <a:avLst/>
+          </a:prstGeom>
+          <a:solidFill>
             <a:srgbClr val="000000">
               <a:alpha val="0"/>
             </a:srgbClr>
           </a:solidFill>
-          <a:ln xmlns:a="http://schemas.openxmlformats.org/drawingml/2006/main" w="0">
-            <a:solidFill>
-              <a:srgbClr val="000000">
-                <a:alpha val="0"/>
-              </a:srgbClr>
-            </a:solidFill>
-            <a:prstDash val="solid"/>
-          </a:ln>
-        </p:spPr>
-        <p:txBody>
-          <a:bodyPr xmlns:a="http://schemas.openxmlformats.org/drawingml/2006/main" lIns="0" tIns="0" rIns="0" bIns="0" anchor="t"/>
-          <a:lstStyle xmlns:a="http://schemas.openxmlformats.org/drawingml/2006/main"/>
-          <a:p xmlns:a="http://schemas.openxmlformats.org/drawingml/2006/main">
+          <a:ln w="0">
+            <a:solidFill>
+              <a:srgbClr val="000000">
+                <a:alpha val="0"/>
+              </a:srgbClr>
+            </a:solidFill>
+            <a:prstDash val="solid"/>
+          </a:ln>
+        </p:spPr>
+        <p:txBody>
+          <a:bodyPr lIns="0" tIns="0" rIns="0" bIns="0" anchor="t"/>
+          <a:lstStyle/>
+          <a:p>
             <a:pPr algn="l">
               <a:defRPr sz="1800" b="1">
                 <a:solidFill>
@@ -12708,43 +12708,43 @@
       <p:sp>
         <p:nvSpPr>
           <p:cNvPr id="16" name="">
-            <a:extLst xmlns:a="http://schemas.openxmlformats.org/drawingml/2006/main">
-              <a:ext uri="{FF2B5EF4-FFF2-40B4-BE49-F238E27FC236}">
-                <a16:creationId xmlns:a16="http://schemas.microsoft.com/office/drawing/2014/main" id="{CFC21A68-4907-493B-89E2-B5A00AFFDAFD}"/>
-              </a:ext>
-            </a:extLst>
-          </p:cNvPr>
-          <p:cNvSpPr>
-            <a:spLocks xmlns:a="http://schemas.openxmlformats.org/drawingml/2006/main" noGrp="1"/>
-          </p:cNvSpPr>
-          <p:nvPr/>
-        </p:nvSpPr>
-        <p:spPr>
-          <a:xfrm xmlns:a="http://schemas.openxmlformats.org/drawingml/2006/main">
+            <a:extLst>
+              <a:ext uri="{FF2B5EF4-FFF2-40B4-BE49-F238E27FC236}">
+                <ns2:creationId id="{CFC21A68-4907-493B-89E2-B5A00AFFDAFD}"/>
+              </a:ext>
+            </a:extLst>
+          </p:cNvPr>
+          <p:cNvSpPr>
+            <a:spLocks noGrp="1"/>
+          </p:cNvSpPr>
+          <p:nvPr/>
+        </p:nvSpPr>
+        <p:spPr>
+          <a:xfrm>
             <a:off x="9201150" y="2857500"/>
             <a:ext cx="1885950" cy="342900"/>
           </a:xfrm>
-          <a:prstGeom xmlns:a="http://schemas.openxmlformats.org/drawingml/2006/main" prst="rect">
-            <a:avLst/>
-          </a:prstGeom>
-          <a:solidFill xmlns:a="http://schemas.openxmlformats.org/drawingml/2006/main">
+          <a:prstGeom prst="rect">
+            <a:avLst/>
+          </a:prstGeom>
+          <a:solidFill>
             <a:srgbClr val="000000">
               <a:alpha val="0"/>
             </a:srgbClr>
           </a:solidFill>
-          <a:ln xmlns:a="http://schemas.openxmlformats.org/drawingml/2006/main" w="0">
-            <a:solidFill>
-              <a:srgbClr val="000000">
-                <a:alpha val="0"/>
-              </a:srgbClr>
-            </a:solidFill>
-            <a:prstDash val="solid"/>
-          </a:ln>
-        </p:spPr>
-        <p:txBody>
-          <a:bodyPr xmlns:a="http://schemas.openxmlformats.org/drawingml/2006/main" lIns="0" tIns="0" rIns="0" bIns="0" anchor="t"/>
-          <a:lstStyle xmlns:a="http://schemas.openxmlformats.org/drawingml/2006/main"/>
-          <a:p xmlns:a="http://schemas.openxmlformats.org/drawingml/2006/main">
+          <a:ln w="0">
+            <a:solidFill>
+              <a:srgbClr val="000000">
+                <a:alpha val="0"/>
+              </a:srgbClr>
+            </a:solidFill>
+            <a:prstDash val="solid"/>
+          </a:ln>
+        </p:spPr>
+        <p:txBody>
+          <a:bodyPr lIns="0" tIns="0" rIns="0" bIns="0" anchor="t"/>
+          <a:lstStyle/>
+          <a:p>
             <a:pPr algn="l">
               <a:defRPr sz="900" b="0">
                 <a:solidFill>
@@ -12772,29 +12772,29 @@
       <p:sp>
         <p:nvSpPr>
           <p:cNvPr id="17" name="">
-            <a:extLst xmlns:a="http://schemas.openxmlformats.org/drawingml/2006/main">
-              <a:ext uri="{FF2B5EF4-FFF2-40B4-BE49-F238E27FC236}">
-                <a16:creationId xmlns:a16="http://schemas.microsoft.com/office/drawing/2014/main" id="{A3D6827C-4C82-4187-A9DE-41E49DD410EE}"/>
-              </a:ext>
-            </a:extLst>
-          </p:cNvPr>
-          <p:cNvSpPr>
-            <a:spLocks xmlns:a="http://schemas.openxmlformats.org/drawingml/2006/main" noGrp="1"/>
-          </p:cNvSpPr>
-          <p:nvPr/>
-        </p:nvSpPr>
-        <p:spPr>
-          <a:xfrm xmlns:a="http://schemas.openxmlformats.org/drawingml/2006/main">
+            <a:extLst>
+              <a:ext uri="{FF2B5EF4-FFF2-40B4-BE49-F238E27FC236}">
+                <ns2:creationId id="{A3D6827C-4C82-4187-A9DE-41E49DD410EE}"/>
+              </a:ext>
+            </a:extLst>
+          </p:cNvPr>
+          <p:cNvSpPr>
+            <a:spLocks noGrp="1"/>
+          </p:cNvSpPr>
+          <p:nvPr/>
+        </p:nvSpPr>
+        <p:spPr>
+          <a:xfrm>
             <a:off x="7429500" y="3276600"/>
             <a:ext cx="2190750" cy="742950"/>
           </a:xfrm>
-          <a:prstGeom xmlns:a="http://schemas.openxmlformats.org/drawingml/2006/main" prst="rect">
-            <a:avLst/>
-          </a:prstGeom>
-          <a:solidFill xmlns:a="http://schemas.openxmlformats.org/drawingml/2006/main">
+          <a:prstGeom prst="rect">
+            <a:avLst/>
+          </a:prstGeom>
+          <a:solidFill>
             <a:srgbClr val="10243A"/>
           </a:solidFill>
-          <a:ln xmlns:a="http://schemas.openxmlformats.org/drawingml/2006/main" w="9525">
+          <a:ln w="9525">
             <a:solidFill>
               <a:srgbClr val="24435F"/>
             </a:solidFill>
@@ -12805,43 +12805,43 @@
       <p:sp>
         <p:nvSpPr>
           <p:cNvPr id="18" name="">
-            <a:extLst xmlns:a="http://schemas.openxmlformats.org/drawingml/2006/main">
-              <a:ext uri="{FF2B5EF4-FFF2-40B4-BE49-F238E27FC236}">
-                <a16:creationId xmlns:a16="http://schemas.microsoft.com/office/drawing/2014/main" id="{604C88D4-56B0-4E83-A8DB-046C63E940DD}"/>
-              </a:ext>
-            </a:extLst>
-          </p:cNvPr>
-          <p:cNvSpPr>
-            <a:spLocks xmlns:a="http://schemas.openxmlformats.org/drawingml/2006/main" noGrp="1"/>
-          </p:cNvSpPr>
-          <p:nvPr/>
-        </p:nvSpPr>
-        <p:spPr>
-          <a:xfrm xmlns:a="http://schemas.openxmlformats.org/drawingml/2006/main">
+            <a:extLst>
+              <a:ext uri="{FF2B5EF4-FFF2-40B4-BE49-F238E27FC236}">
+                <ns2:creationId id="{604C88D4-56B0-4E83-A8DB-046C63E940DD}"/>
+              </a:ext>
+            </a:extLst>
+          </p:cNvPr>
+          <p:cNvSpPr>
+            <a:spLocks noGrp="1"/>
+          </p:cNvSpPr>
+          <p:nvPr/>
+        </p:nvSpPr>
+        <p:spPr>
+          <a:xfrm>
             <a:off x="7581900" y="3409950"/>
             <a:ext cx="1885950" cy="323850"/>
           </a:xfrm>
-          <a:prstGeom xmlns:a="http://schemas.openxmlformats.org/drawingml/2006/main" prst="rect">
-            <a:avLst/>
-          </a:prstGeom>
-          <a:solidFill xmlns:a="http://schemas.openxmlformats.org/drawingml/2006/main">
+          <a:prstGeom prst="rect">
+            <a:avLst/>
+          </a:prstGeom>
+          <a:solidFill>
             <a:srgbClr val="000000">
               <a:alpha val="0"/>
             </a:srgbClr>
           </a:solidFill>
-          <a:ln xmlns:a="http://schemas.openxmlformats.org/drawingml/2006/main" w="0">
-            <a:solidFill>
-              <a:srgbClr val="000000">
-                <a:alpha val="0"/>
-              </a:srgbClr>
-            </a:solidFill>
-            <a:prstDash val="solid"/>
-          </a:ln>
-        </p:spPr>
-        <p:txBody>
-          <a:bodyPr xmlns:a="http://schemas.openxmlformats.org/drawingml/2006/main" lIns="0" tIns="0" rIns="0" bIns="0" anchor="t"/>
-          <a:lstStyle xmlns:a="http://schemas.openxmlformats.org/drawingml/2006/main"/>
-          <a:p xmlns:a="http://schemas.openxmlformats.org/drawingml/2006/main">
+          <a:ln w="0">
+            <a:solidFill>
+              <a:srgbClr val="000000">
+                <a:alpha val="0"/>
+              </a:srgbClr>
+            </a:solidFill>
+            <a:prstDash val="solid"/>
+          </a:ln>
+        </p:spPr>
+        <p:txBody>
+          <a:bodyPr lIns="0" tIns="0" rIns="0" bIns="0" anchor="t"/>
+          <a:lstStyle/>
+          <a:p>
             <a:pPr algn="l">
               <a:defRPr sz="1800" b="1">
                 <a:solidFill>
@@ -12869,43 +12869,43 @@
       <p:sp>
         <p:nvSpPr>
           <p:cNvPr id="19" name="">
-            <a:extLst xmlns:a="http://schemas.openxmlformats.org/drawingml/2006/main">
-              <a:ext uri="{FF2B5EF4-FFF2-40B4-BE49-F238E27FC236}">
-                <a16:creationId xmlns:a16="http://schemas.microsoft.com/office/drawing/2014/main" id="{11CB2E16-C55C-4468-9603-24975533B9C8}"/>
-              </a:ext>
-            </a:extLst>
-          </p:cNvPr>
-          <p:cNvSpPr>
-            <a:spLocks xmlns:a="http://schemas.openxmlformats.org/drawingml/2006/main" noGrp="1"/>
-          </p:cNvSpPr>
-          <p:nvPr/>
-        </p:nvSpPr>
-        <p:spPr>
-          <a:xfrm xmlns:a="http://schemas.openxmlformats.org/drawingml/2006/main">
+            <a:extLst>
+              <a:ext uri="{FF2B5EF4-FFF2-40B4-BE49-F238E27FC236}">
+                <ns2:creationId id="{11CB2E16-C55C-4468-9603-24975533B9C8}"/>
+              </a:ext>
+            </a:extLst>
+          </p:cNvPr>
+          <p:cNvSpPr>
+            <a:spLocks noGrp="1"/>
+          </p:cNvSpPr>
+          <p:nvPr/>
+        </p:nvSpPr>
+        <p:spPr>
+          <a:xfrm>
             <a:off x="7581900" y="3771900"/>
             <a:ext cx="1885950" cy="342900"/>
           </a:xfrm>
-          <a:prstGeom xmlns:a="http://schemas.openxmlformats.org/drawingml/2006/main" prst="rect">
-            <a:avLst/>
-          </a:prstGeom>
-          <a:solidFill xmlns:a="http://schemas.openxmlformats.org/drawingml/2006/main">
+          <a:prstGeom prst="rect">
+            <a:avLst/>
+          </a:prstGeom>
+          <a:solidFill>
             <a:srgbClr val="000000">
               <a:alpha val="0"/>
             </a:srgbClr>
           </a:solidFill>
-          <a:ln xmlns:a="http://schemas.openxmlformats.org/drawingml/2006/main" w="0">
-            <a:solidFill>
-              <a:srgbClr val="000000">
-                <a:alpha val="0"/>
-              </a:srgbClr>
-            </a:solidFill>
-            <a:prstDash val="solid"/>
-          </a:ln>
-        </p:spPr>
-        <p:txBody>
-          <a:bodyPr xmlns:a="http://schemas.openxmlformats.org/drawingml/2006/main" lIns="0" tIns="0" rIns="0" bIns="0" anchor="t"/>
-          <a:lstStyle xmlns:a="http://schemas.openxmlformats.org/drawingml/2006/main"/>
-          <a:p xmlns:a="http://schemas.openxmlformats.org/drawingml/2006/main">
+          <a:ln w="0">
+            <a:solidFill>
+              <a:srgbClr val="000000">
+                <a:alpha val="0"/>
+              </a:srgbClr>
+            </a:solidFill>
+            <a:prstDash val="solid"/>
+          </a:ln>
+        </p:spPr>
+        <p:txBody>
+          <a:bodyPr lIns="0" tIns="0" rIns="0" bIns="0" anchor="t"/>
+          <a:lstStyle/>
+          <a:p>
             <a:pPr algn="l">
               <a:defRPr sz="900" b="0">
                 <a:solidFill>
@@ -12933,29 +12933,29 @@
       <p:sp>
         <p:nvSpPr>
           <p:cNvPr id="20" name="">
-            <a:extLst xmlns:a="http://schemas.openxmlformats.org/drawingml/2006/main">
-              <a:ext uri="{FF2B5EF4-FFF2-40B4-BE49-F238E27FC236}">
-                <a16:creationId xmlns:a16="http://schemas.microsoft.com/office/drawing/2014/main" id="{CFDB130B-9332-4691-A43A-C8D9EB3097DA}"/>
-              </a:ext>
-            </a:extLst>
-          </p:cNvPr>
-          <p:cNvSpPr>
-            <a:spLocks xmlns:a="http://schemas.openxmlformats.org/drawingml/2006/main" noGrp="1"/>
-          </p:cNvSpPr>
-          <p:nvPr/>
-        </p:nvSpPr>
-        <p:spPr>
-          <a:xfrm xmlns:a="http://schemas.openxmlformats.org/drawingml/2006/main">
+            <a:extLst>
+              <a:ext uri="{FF2B5EF4-FFF2-40B4-BE49-F238E27FC236}">
+                <ns2:creationId id="{CFDB130B-9332-4691-A43A-C8D9EB3097DA}"/>
+              </a:ext>
+            </a:extLst>
+          </p:cNvPr>
+          <p:cNvSpPr>
+            <a:spLocks noGrp="1"/>
+          </p:cNvSpPr>
+          <p:nvPr/>
+        </p:nvSpPr>
+        <p:spPr>
+          <a:xfrm>
             <a:off x="666750" y="4686300"/>
             <a:ext cx="10572750" cy="819150"/>
           </a:xfrm>
-          <a:prstGeom xmlns:a="http://schemas.openxmlformats.org/drawingml/2006/main" prst="rect">
-            <a:avLst/>
-          </a:prstGeom>
-          <a:solidFill xmlns:a="http://schemas.openxmlformats.org/drawingml/2006/main">
+          <a:prstGeom prst="rect">
+            <a:avLst/>
+          </a:prstGeom>
+          <a:solidFill>
             <a:srgbClr val="10243A"/>
           </a:solidFill>
-          <a:ln xmlns:a="http://schemas.openxmlformats.org/drawingml/2006/main" w="9525">
+          <a:ln w="9525">
             <a:solidFill>
               <a:srgbClr val="24435F"/>
             </a:solidFill>
@@ -12966,43 +12966,43 @@
       <p:sp>
         <p:nvSpPr>
           <p:cNvPr id="21" name="">
-            <a:extLst xmlns:a="http://schemas.openxmlformats.org/drawingml/2006/main">
-              <a:ext uri="{FF2B5EF4-FFF2-40B4-BE49-F238E27FC236}">
-                <a16:creationId xmlns:a16="http://schemas.microsoft.com/office/drawing/2014/main" id="{755E5EB6-A451-4CB7-95E0-04F2A7AD866E}"/>
-              </a:ext>
-            </a:extLst>
-          </p:cNvPr>
-          <p:cNvSpPr>
-            <a:spLocks xmlns:a="http://schemas.openxmlformats.org/drawingml/2006/main" noGrp="1"/>
-          </p:cNvSpPr>
-          <p:nvPr/>
-        </p:nvSpPr>
-        <p:spPr>
-          <a:xfrm xmlns:a="http://schemas.openxmlformats.org/drawingml/2006/main">
+            <a:extLst>
+              <a:ext uri="{FF2B5EF4-FFF2-40B4-BE49-F238E27FC236}">
+                <ns2:creationId id="{755E5EB6-A451-4CB7-95E0-04F2A7AD866E}"/>
+              </a:ext>
+            </a:extLst>
+          </p:cNvPr>
+          <p:cNvSpPr>
+            <a:spLocks noGrp="1"/>
+          </p:cNvSpPr>
+          <p:nvPr/>
+        </p:nvSpPr>
+        <p:spPr>
+          <a:xfrm>
             <a:off x="895350" y="4857750"/>
             <a:ext cx="2286000" cy="190500"/>
           </a:xfrm>
-          <a:prstGeom xmlns:a="http://schemas.openxmlformats.org/drawingml/2006/main" prst="rect">
-            <a:avLst/>
-          </a:prstGeom>
-          <a:solidFill xmlns:a="http://schemas.openxmlformats.org/drawingml/2006/main">
+          <a:prstGeom prst="rect">
+            <a:avLst/>
+          </a:prstGeom>
+          <a:solidFill>
             <a:srgbClr val="000000">
               <a:alpha val="0"/>
             </a:srgbClr>
           </a:solidFill>
-          <a:ln xmlns:a="http://schemas.openxmlformats.org/drawingml/2006/main" w="0">
-            <a:solidFill>
-              <a:srgbClr val="000000">
-                <a:alpha val="0"/>
-              </a:srgbClr>
-            </a:solidFill>
-            <a:prstDash val="solid"/>
-          </a:ln>
-        </p:spPr>
-        <p:txBody>
-          <a:bodyPr xmlns:a="http://schemas.openxmlformats.org/drawingml/2006/main" lIns="0" tIns="0" rIns="0" bIns="0" anchor="t"/>
-          <a:lstStyle xmlns:a="http://schemas.openxmlformats.org/drawingml/2006/main"/>
-          <a:p xmlns:a="http://schemas.openxmlformats.org/drawingml/2006/main">
+          <a:ln w="0">
+            <a:solidFill>
+              <a:srgbClr val="000000">
+                <a:alpha val="0"/>
+              </a:srgbClr>
+            </a:solidFill>
+            <a:prstDash val="solid"/>
+          </a:ln>
+        </p:spPr>
+        <p:txBody>
+          <a:bodyPr lIns="0" tIns="0" rIns="0" bIns="0" anchor="t"/>
+          <a:lstStyle/>
+          <a:p>
             <a:pPr algn="l">
               <a:defRPr sz="1275" b="1">
                 <a:solidFill>
@@ -13030,29 +13030,29 @@
       <p:sp>
         <p:nvSpPr>
           <p:cNvPr id="22" name="">
-            <a:extLst xmlns:a="http://schemas.openxmlformats.org/drawingml/2006/main">
-              <a:ext uri="{FF2B5EF4-FFF2-40B4-BE49-F238E27FC236}">
-                <a16:creationId xmlns:a16="http://schemas.microsoft.com/office/drawing/2014/main" id="{B9E89E58-3E8C-4E89-8815-9004BD1758C9}"/>
-              </a:ext>
-            </a:extLst>
-          </p:cNvPr>
-          <p:cNvSpPr>
-            <a:spLocks xmlns:a="http://schemas.openxmlformats.org/drawingml/2006/main" noGrp="1"/>
-          </p:cNvSpPr>
-          <p:nvPr/>
-        </p:nvSpPr>
-        <p:spPr>
-          <a:xfrm xmlns:a="http://schemas.openxmlformats.org/drawingml/2006/main">
+            <a:extLst>
+              <a:ext uri="{FF2B5EF4-FFF2-40B4-BE49-F238E27FC236}">
+                <ns2:creationId id="{B9E89E58-3E8C-4E89-8815-9004BD1758C9}"/>
+              </a:ext>
+            </a:extLst>
+          </p:cNvPr>
+          <p:cNvSpPr>
+            <a:spLocks noGrp="1"/>
+          </p:cNvSpPr>
+          <p:nvPr/>
+        </p:nvSpPr>
+        <p:spPr>
+          <a:xfrm>
             <a:off x="3314700" y="4876800"/>
             <a:ext cx="1047750" cy="400050"/>
           </a:xfrm>
-          <a:prstGeom xmlns:a="http://schemas.openxmlformats.org/drawingml/2006/main" prst="rect">
-            <a:avLst/>
-          </a:prstGeom>
-          <a:solidFill xmlns:a="http://schemas.openxmlformats.org/drawingml/2006/main">
+          <a:prstGeom prst="rect">
+            <a:avLst/>
+          </a:prstGeom>
+          <a:solidFill>
             <a:srgbClr val="10243A"/>
           </a:solidFill>
-          <a:ln xmlns:a="http://schemas.openxmlformats.org/drawingml/2006/main" w="9525">
+          <a:ln w="9525">
             <a:solidFill>
               <a:srgbClr val="80CBC4"/>
             </a:solidFill>
@@ -13063,43 +13063,43 @@
       <p:sp>
         <p:nvSpPr>
           <p:cNvPr id="23" name="">
-            <a:extLst xmlns:a="http://schemas.openxmlformats.org/drawingml/2006/main">
-              <a:ext uri="{FF2B5EF4-FFF2-40B4-BE49-F238E27FC236}">
-                <a16:creationId xmlns:a16="http://schemas.microsoft.com/office/drawing/2014/main" id="{A82EDEB8-1369-4D60-B8D8-3BA32523F927}"/>
-              </a:ext>
-            </a:extLst>
-          </p:cNvPr>
-          <p:cNvSpPr>
-            <a:spLocks xmlns:a="http://schemas.openxmlformats.org/drawingml/2006/main" noGrp="1"/>
-          </p:cNvSpPr>
-          <p:nvPr/>
-        </p:nvSpPr>
-        <p:spPr>
-          <a:xfrm xmlns:a="http://schemas.openxmlformats.org/drawingml/2006/main">
+            <a:extLst>
+              <a:ext uri="{FF2B5EF4-FFF2-40B4-BE49-F238E27FC236}">
+                <ns2:creationId id="{A82EDEB8-1369-4D60-B8D8-3BA32523F927}"/>
+              </a:ext>
+            </a:extLst>
+          </p:cNvPr>
+          <p:cNvSpPr>
+            <a:spLocks noGrp="1"/>
+          </p:cNvSpPr>
+          <p:nvPr/>
+        </p:nvSpPr>
+        <p:spPr>
+          <a:xfrm>
             <a:off x="3390900" y="4991100"/>
             <a:ext cx="895350" cy="171450"/>
           </a:xfrm>
-          <a:prstGeom xmlns:a="http://schemas.openxmlformats.org/drawingml/2006/main" prst="rect">
-            <a:avLst/>
-          </a:prstGeom>
-          <a:solidFill xmlns:a="http://schemas.openxmlformats.org/drawingml/2006/main">
+          <a:prstGeom prst="rect">
+            <a:avLst/>
+          </a:prstGeom>
+          <a:solidFill>
             <a:srgbClr val="000000">
               <a:alpha val="0"/>
             </a:srgbClr>
           </a:solidFill>
-          <a:ln xmlns:a="http://schemas.openxmlformats.org/drawingml/2006/main" w="0">
-            <a:solidFill>
-              <a:srgbClr val="000000">
-                <a:alpha val="0"/>
-              </a:srgbClr>
-            </a:solidFill>
-            <a:prstDash val="solid"/>
-          </a:ln>
-        </p:spPr>
-        <p:txBody>
-          <a:bodyPr xmlns:a="http://schemas.openxmlformats.org/drawingml/2006/main" lIns="0" tIns="0" rIns="0" bIns="0" anchor="t"/>
-          <a:lstStyle xmlns:a="http://schemas.openxmlformats.org/drawingml/2006/main"/>
-          <a:p xmlns:a="http://schemas.openxmlformats.org/drawingml/2006/main">
+          <a:ln w="0">
+            <a:solidFill>
+              <a:srgbClr val="000000">
+                <a:alpha val="0"/>
+              </a:srgbClr>
+            </a:solidFill>
+            <a:prstDash val="solid"/>
+          </a:ln>
+        </p:spPr>
+        <p:txBody>
+          <a:bodyPr lIns="0" tIns="0" rIns="0" bIns="0" anchor="t"/>
+          <a:lstStyle/>
+          <a:p>
             <a:pPr algn="ctr">
               <a:defRPr sz="825" b="1">
                 <a:solidFill>
@@ -13127,29 +13127,29 @@
       <p:sp>
         <p:nvSpPr>
           <p:cNvPr id="24" name="">
-            <a:extLst xmlns:a="http://schemas.openxmlformats.org/drawingml/2006/main">
-              <a:ext uri="{FF2B5EF4-FFF2-40B4-BE49-F238E27FC236}">
-                <a16:creationId xmlns:a16="http://schemas.microsoft.com/office/drawing/2014/main" id="{3A1DB191-3E97-422B-BAAD-B012CBFB8124}"/>
-              </a:ext>
-            </a:extLst>
-          </p:cNvPr>
-          <p:cNvSpPr>
-            <a:spLocks xmlns:a="http://schemas.openxmlformats.org/drawingml/2006/main" noGrp="1"/>
-          </p:cNvSpPr>
-          <p:nvPr/>
-        </p:nvSpPr>
-        <p:spPr>
-          <a:xfrm xmlns:a="http://schemas.openxmlformats.org/drawingml/2006/main">
+            <a:extLst>
+              <a:ext uri="{FF2B5EF4-FFF2-40B4-BE49-F238E27FC236}">
+                <ns2:creationId id="{3A1DB191-3E97-422B-BAAD-B012CBFB8124}"/>
+              </a:ext>
+            </a:extLst>
+          </p:cNvPr>
+          <p:cNvSpPr>
+            <a:spLocks noGrp="1"/>
+          </p:cNvSpPr>
+          <p:nvPr/>
+        </p:nvSpPr>
+        <p:spPr>
+          <a:xfrm>
             <a:off x="4400550" y="5067300"/>
             <a:ext cx="190500" cy="28575"/>
           </a:xfrm>
-          <a:prstGeom xmlns:a="http://schemas.openxmlformats.org/drawingml/2006/main" prst="rect">
-            <a:avLst/>
-          </a:prstGeom>
-          <a:solidFill xmlns:a="http://schemas.openxmlformats.org/drawingml/2006/main">
+          <a:prstGeom prst="rect">
+            <a:avLst/>
+          </a:prstGeom>
+          <a:solidFill>
             <a:srgbClr val="80CBC4"/>
           </a:solidFill>
-          <a:ln xmlns:a="http://schemas.openxmlformats.org/drawingml/2006/main" w="0">
+          <a:ln w="0">
             <a:solidFill>
               <a:srgbClr val="80CBC4"/>
             </a:solidFill>
@@ -13160,29 +13160,29 @@
       <p:sp>
         <p:nvSpPr>
           <p:cNvPr id="25" name="">
-            <a:extLst xmlns:a="http://schemas.openxmlformats.org/drawingml/2006/main">
-              <a:ext uri="{FF2B5EF4-FFF2-40B4-BE49-F238E27FC236}">
-                <a16:creationId xmlns:a16="http://schemas.microsoft.com/office/drawing/2014/main" id="{63EEC7F0-2D84-4B91-A7A5-C2E0CA41E779}"/>
-              </a:ext>
-            </a:extLst>
-          </p:cNvPr>
-          <p:cNvSpPr>
-            <a:spLocks xmlns:a="http://schemas.openxmlformats.org/drawingml/2006/main" noGrp="1"/>
-          </p:cNvSpPr>
-          <p:nvPr/>
-        </p:nvSpPr>
-        <p:spPr>
-          <a:xfrm xmlns:a="http://schemas.openxmlformats.org/drawingml/2006/main">
+            <a:extLst>
+              <a:ext uri="{FF2B5EF4-FFF2-40B4-BE49-F238E27FC236}">
+                <ns2:creationId id="{63EEC7F0-2D84-4B91-A7A5-C2E0CA41E779}"/>
+              </a:ext>
+            </a:extLst>
+          </p:cNvPr>
+          <p:cNvSpPr>
+            <a:spLocks noGrp="1"/>
+          </p:cNvSpPr>
+          <p:nvPr/>
+        </p:nvSpPr>
+        <p:spPr>
+          <a:xfrm>
             <a:off x="4629150" y="4876800"/>
             <a:ext cx="1047750" cy="400050"/>
           </a:xfrm>
-          <a:prstGeom xmlns:a="http://schemas.openxmlformats.org/drawingml/2006/main" prst="rect">
-            <a:avLst/>
-          </a:prstGeom>
-          <a:solidFill xmlns:a="http://schemas.openxmlformats.org/drawingml/2006/main">
+          <a:prstGeom prst="rect">
+            <a:avLst/>
+          </a:prstGeom>
+          <a:solidFill>
             <a:srgbClr val="10243A"/>
           </a:solidFill>
-          <a:ln xmlns:a="http://schemas.openxmlformats.org/drawingml/2006/main" w="9525">
+          <a:ln w="9525">
             <a:solidFill>
               <a:srgbClr val="80CBC4"/>
             </a:solidFill>
@@ -13193,43 +13193,43 @@
       <p:sp>
         <p:nvSpPr>
           <p:cNvPr id="26" name="">
-            <a:extLst xmlns:a="http://schemas.openxmlformats.org/drawingml/2006/main">
-              <a:ext uri="{FF2B5EF4-FFF2-40B4-BE49-F238E27FC236}">
-                <a16:creationId xmlns:a16="http://schemas.microsoft.com/office/drawing/2014/main" id="{0B0F9F81-5D89-4DD1-B3DF-80641C62512A}"/>
-              </a:ext>
-            </a:extLst>
-          </p:cNvPr>
-          <p:cNvSpPr>
-            <a:spLocks xmlns:a="http://schemas.openxmlformats.org/drawingml/2006/main" noGrp="1"/>
-          </p:cNvSpPr>
-          <p:nvPr/>
-        </p:nvSpPr>
-        <p:spPr>
-          <a:xfrm xmlns:a="http://schemas.openxmlformats.org/drawingml/2006/main">
+            <a:extLst>
+              <a:ext uri="{FF2B5EF4-FFF2-40B4-BE49-F238E27FC236}">
+                <ns2:creationId id="{0B0F9F81-5D89-4DD1-B3DF-80641C62512A}"/>
+              </a:ext>
+            </a:extLst>
+          </p:cNvPr>
+          <p:cNvSpPr>
+            <a:spLocks noGrp="1"/>
+          </p:cNvSpPr>
+          <p:nvPr/>
+        </p:nvSpPr>
+        <p:spPr>
+          <a:xfrm>
             <a:off x="4705350" y="4991100"/>
             <a:ext cx="895350" cy="171450"/>
           </a:xfrm>
-          <a:prstGeom xmlns:a="http://schemas.openxmlformats.org/drawingml/2006/main" prst="rect">
-            <a:avLst/>
-          </a:prstGeom>
-          <a:solidFill xmlns:a="http://schemas.openxmlformats.org/drawingml/2006/main">
+          <a:prstGeom prst="rect">
+            <a:avLst/>
+          </a:prstGeom>
+          <a:solidFill>
             <a:srgbClr val="000000">
               <a:alpha val="0"/>
             </a:srgbClr>
           </a:solidFill>
-          <a:ln xmlns:a="http://schemas.openxmlformats.org/drawingml/2006/main" w="0">
-            <a:solidFill>
-              <a:srgbClr val="000000">
-                <a:alpha val="0"/>
-              </a:srgbClr>
-            </a:solidFill>
-            <a:prstDash val="solid"/>
-          </a:ln>
-        </p:spPr>
-        <p:txBody>
-          <a:bodyPr xmlns:a="http://schemas.openxmlformats.org/drawingml/2006/main" lIns="0" tIns="0" rIns="0" bIns="0" anchor="t"/>
-          <a:lstStyle xmlns:a="http://schemas.openxmlformats.org/drawingml/2006/main"/>
-          <a:p xmlns:a="http://schemas.openxmlformats.org/drawingml/2006/main">
+          <a:ln w="0">
+            <a:solidFill>
+              <a:srgbClr val="000000">
+                <a:alpha val="0"/>
+              </a:srgbClr>
+            </a:solidFill>
+            <a:prstDash val="solid"/>
+          </a:ln>
+        </p:spPr>
+        <p:txBody>
+          <a:bodyPr lIns="0" tIns="0" rIns="0" bIns="0" anchor="t"/>
+          <a:lstStyle/>
+          <a:p>
             <a:pPr algn="ctr">
               <a:defRPr sz="825" b="1">
                 <a:solidFill>
@@ -13257,29 +13257,29 @@
       <p:sp>
         <p:nvSpPr>
           <p:cNvPr id="27" name="">
-            <a:extLst xmlns:a="http://schemas.openxmlformats.org/drawingml/2006/main">
-              <a:ext uri="{FF2B5EF4-FFF2-40B4-BE49-F238E27FC236}">
-                <a16:creationId xmlns:a16="http://schemas.microsoft.com/office/drawing/2014/main" id="{DBADF894-0E40-4151-B0B3-CB77CA367365}"/>
-              </a:ext>
-            </a:extLst>
-          </p:cNvPr>
-          <p:cNvSpPr>
-            <a:spLocks xmlns:a="http://schemas.openxmlformats.org/drawingml/2006/main" noGrp="1"/>
-          </p:cNvSpPr>
-          <p:nvPr/>
-        </p:nvSpPr>
-        <p:spPr>
-          <a:xfrm xmlns:a="http://schemas.openxmlformats.org/drawingml/2006/main">
+            <a:extLst>
+              <a:ext uri="{FF2B5EF4-FFF2-40B4-BE49-F238E27FC236}">
+                <ns2:creationId id="{DBADF894-0E40-4151-B0B3-CB77CA367365}"/>
+              </a:ext>
+            </a:extLst>
+          </p:cNvPr>
+          <p:cNvSpPr>
+            <a:spLocks noGrp="1"/>
+          </p:cNvSpPr>
+          <p:nvPr/>
+        </p:nvSpPr>
+        <p:spPr>
+          <a:xfrm>
             <a:off x="5715000" y="5067300"/>
             <a:ext cx="190500" cy="28575"/>
           </a:xfrm>
-          <a:prstGeom xmlns:a="http://schemas.openxmlformats.org/drawingml/2006/main" prst="rect">
-            <a:avLst/>
-          </a:prstGeom>
-          <a:solidFill xmlns:a="http://schemas.openxmlformats.org/drawingml/2006/main">
+          <a:prstGeom prst="rect">
+            <a:avLst/>
+          </a:prstGeom>
+          <a:solidFill>
             <a:srgbClr val="80CBC4"/>
           </a:solidFill>
-          <a:ln xmlns:a="http://schemas.openxmlformats.org/drawingml/2006/main" w="0">
+          <a:ln w="0">
             <a:solidFill>
               <a:srgbClr val="80CBC4"/>
             </a:solidFill>
@@ -13290,29 +13290,29 @@
       <p:sp>
         <p:nvSpPr>
           <p:cNvPr id="28" name="">
-            <a:extLst xmlns:a="http://schemas.openxmlformats.org/drawingml/2006/main">
-              <a:ext uri="{FF2B5EF4-FFF2-40B4-BE49-F238E27FC236}">
-                <a16:creationId xmlns:a16="http://schemas.microsoft.com/office/drawing/2014/main" id="{E52C8B7F-6F3D-44AB-BB43-6131047D8678}"/>
-              </a:ext>
-            </a:extLst>
-          </p:cNvPr>
-          <p:cNvSpPr>
-            <a:spLocks xmlns:a="http://schemas.openxmlformats.org/drawingml/2006/main" noGrp="1"/>
-          </p:cNvSpPr>
-          <p:nvPr/>
-        </p:nvSpPr>
-        <p:spPr>
-          <a:xfrm xmlns:a="http://schemas.openxmlformats.org/drawingml/2006/main">
+            <a:extLst>
+              <a:ext uri="{FF2B5EF4-FFF2-40B4-BE49-F238E27FC236}">
+                <ns2:creationId id="{E52C8B7F-6F3D-44AB-BB43-6131047D8678}"/>
+              </a:ext>
+            </a:extLst>
+          </p:cNvPr>
+          <p:cNvSpPr>
+            <a:spLocks noGrp="1"/>
+          </p:cNvSpPr>
+          <p:nvPr/>
+        </p:nvSpPr>
+        <p:spPr>
+          <a:xfrm>
             <a:off x="5943600" y="4876800"/>
             <a:ext cx="1047750" cy="400050"/>
           </a:xfrm>
-          <a:prstGeom xmlns:a="http://schemas.openxmlformats.org/drawingml/2006/main" prst="rect">
-            <a:avLst/>
-          </a:prstGeom>
-          <a:solidFill xmlns:a="http://schemas.openxmlformats.org/drawingml/2006/main">
+          <a:prstGeom prst="rect">
+            <a:avLst/>
+          </a:prstGeom>
+          <a:solidFill>
             <a:srgbClr val="10243A"/>
           </a:solidFill>
-          <a:ln xmlns:a="http://schemas.openxmlformats.org/drawingml/2006/main" w="9525">
+          <a:ln w="9525">
             <a:solidFill>
               <a:srgbClr val="80CBC4"/>
             </a:solidFill>
@@ -13323,43 +13323,43 @@
       <p:sp>
         <p:nvSpPr>
           <p:cNvPr id="29" name="">
-            <a:extLst xmlns:a="http://schemas.openxmlformats.org/drawingml/2006/main">
-              <a:ext uri="{FF2B5EF4-FFF2-40B4-BE49-F238E27FC236}">
-                <a16:creationId xmlns:a16="http://schemas.microsoft.com/office/drawing/2014/main" id="{4E97CDC5-A266-4061-94BD-6458B5FB09A0}"/>
-              </a:ext>
-            </a:extLst>
-          </p:cNvPr>
-          <p:cNvSpPr>
-            <a:spLocks xmlns:a="http://schemas.openxmlformats.org/drawingml/2006/main" noGrp="1"/>
-          </p:cNvSpPr>
-          <p:nvPr/>
-        </p:nvSpPr>
-        <p:spPr>
-          <a:xfrm xmlns:a="http://schemas.openxmlformats.org/drawingml/2006/main">
+            <a:extLst>
+              <a:ext uri="{FF2B5EF4-FFF2-40B4-BE49-F238E27FC236}">
+                <ns2:creationId id="{4E97CDC5-A266-4061-94BD-6458B5FB09A0}"/>
+              </a:ext>
+            </a:extLst>
+          </p:cNvPr>
+          <p:cNvSpPr>
+            <a:spLocks noGrp="1"/>
+          </p:cNvSpPr>
+          <p:nvPr/>
+        </p:nvSpPr>
+        <p:spPr>
+          <a:xfrm>
             <a:off x="6019800" y="4991100"/>
             <a:ext cx="895350" cy="171450"/>
           </a:xfrm>
-          <a:prstGeom xmlns:a="http://schemas.openxmlformats.org/drawingml/2006/main" prst="rect">
-            <a:avLst/>
-          </a:prstGeom>
-          <a:solidFill xmlns:a="http://schemas.openxmlformats.org/drawingml/2006/main">
+          <a:prstGeom prst="rect">
+            <a:avLst/>
+          </a:prstGeom>
+          <a:solidFill>
             <a:srgbClr val="000000">
               <a:alpha val="0"/>
             </a:srgbClr>
           </a:solidFill>
-          <a:ln xmlns:a="http://schemas.openxmlformats.org/drawingml/2006/main" w="0">
-            <a:solidFill>
-              <a:srgbClr val="000000">
-                <a:alpha val="0"/>
-              </a:srgbClr>
-            </a:solidFill>
-            <a:prstDash val="solid"/>
-          </a:ln>
-        </p:spPr>
-        <p:txBody>
-          <a:bodyPr xmlns:a="http://schemas.openxmlformats.org/drawingml/2006/main" lIns="0" tIns="0" rIns="0" bIns="0" anchor="t"/>
-          <a:lstStyle xmlns:a="http://schemas.openxmlformats.org/drawingml/2006/main"/>
-          <a:p xmlns:a="http://schemas.openxmlformats.org/drawingml/2006/main">
+          <a:ln w="0">
+            <a:solidFill>
+              <a:srgbClr val="000000">
+                <a:alpha val="0"/>
+              </a:srgbClr>
+            </a:solidFill>
+            <a:prstDash val="solid"/>
+          </a:ln>
+        </p:spPr>
+        <p:txBody>
+          <a:bodyPr lIns="0" tIns="0" rIns="0" bIns="0" anchor="t"/>
+          <a:lstStyle/>
+          <a:p>
             <a:pPr algn="ctr">
               <a:defRPr sz="825" b="1">
                 <a:solidFill>
@@ -13387,29 +13387,29 @@
       <p:sp>
         <p:nvSpPr>
           <p:cNvPr id="30" name="">
-            <a:extLst xmlns:a="http://schemas.openxmlformats.org/drawingml/2006/main">
-              <a:ext uri="{FF2B5EF4-FFF2-40B4-BE49-F238E27FC236}">
-                <a16:creationId xmlns:a16="http://schemas.microsoft.com/office/drawing/2014/main" id="{4A256028-3F7D-44D4-9777-C1047B79A93E}"/>
-              </a:ext>
-            </a:extLst>
-          </p:cNvPr>
-          <p:cNvSpPr>
-            <a:spLocks xmlns:a="http://schemas.openxmlformats.org/drawingml/2006/main" noGrp="1"/>
-          </p:cNvSpPr>
-          <p:nvPr/>
-        </p:nvSpPr>
-        <p:spPr>
-          <a:xfrm xmlns:a="http://schemas.openxmlformats.org/drawingml/2006/main">
+            <a:extLst>
+              <a:ext uri="{FF2B5EF4-FFF2-40B4-BE49-F238E27FC236}">
+                <ns2:creationId id="{4A256028-3F7D-44D4-9777-C1047B79A93E}"/>
+              </a:ext>
+            </a:extLst>
+          </p:cNvPr>
+          <p:cNvSpPr>
+            <a:spLocks noGrp="1"/>
+          </p:cNvSpPr>
+          <p:nvPr/>
+        </p:nvSpPr>
+        <p:spPr>
+          <a:xfrm>
             <a:off x="7029450" y="5067300"/>
             <a:ext cx="190500" cy="28575"/>
           </a:xfrm>
-          <a:prstGeom xmlns:a="http://schemas.openxmlformats.org/drawingml/2006/main" prst="rect">
-            <a:avLst/>
-          </a:prstGeom>
-          <a:solidFill xmlns:a="http://schemas.openxmlformats.org/drawingml/2006/main">
+          <a:prstGeom prst="rect">
+            <a:avLst/>
+          </a:prstGeom>
+          <a:solidFill>
             <a:srgbClr val="80CBC4"/>
           </a:solidFill>
-          <a:ln xmlns:a="http://schemas.openxmlformats.org/drawingml/2006/main" w="0">
+          <a:ln w="0">
             <a:solidFill>
               <a:srgbClr val="80CBC4"/>
             </a:solidFill>
@@ -13420,29 +13420,29 @@
       <p:sp>
         <p:nvSpPr>
           <p:cNvPr id="31" name="">
-            <a:extLst xmlns:a="http://schemas.openxmlformats.org/drawingml/2006/main">
-              <a:ext uri="{FF2B5EF4-FFF2-40B4-BE49-F238E27FC236}">
-                <a16:creationId xmlns:a16="http://schemas.microsoft.com/office/drawing/2014/main" id="{38906E15-3B3A-4C48-94B5-5B6E38B89F8D}"/>
-              </a:ext>
-            </a:extLst>
-          </p:cNvPr>
-          <p:cNvSpPr>
-            <a:spLocks xmlns:a="http://schemas.openxmlformats.org/drawingml/2006/main" noGrp="1"/>
-          </p:cNvSpPr>
-          <p:nvPr/>
-        </p:nvSpPr>
-        <p:spPr>
-          <a:xfrm xmlns:a="http://schemas.openxmlformats.org/drawingml/2006/main">
+            <a:extLst>
+              <a:ext uri="{FF2B5EF4-FFF2-40B4-BE49-F238E27FC236}">
+                <ns2:creationId id="{38906E15-3B3A-4C48-94B5-5B6E38B89F8D}"/>
+              </a:ext>
+            </a:extLst>
+          </p:cNvPr>
+          <p:cNvSpPr>
+            <a:spLocks noGrp="1"/>
+          </p:cNvSpPr>
+          <p:nvPr/>
+        </p:nvSpPr>
+        <p:spPr>
+          <a:xfrm>
             <a:off x="7258050" y="4876800"/>
             <a:ext cx="1047750" cy="400050"/>
           </a:xfrm>
-          <a:prstGeom xmlns:a="http://schemas.openxmlformats.org/drawingml/2006/main" prst="rect">
-            <a:avLst/>
-          </a:prstGeom>
-          <a:solidFill xmlns:a="http://schemas.openxmlformats.org/drawingml/2006/main">
+          <a:prstGeom prst="rect">
+            <a:avLst/>
+          </a:prstGeom>
+          <a:solidFill>
             <a:srgbClr val="10243A"/>
           </a:solidFill>
-          <a:ln xmlns:a="http://schemas.openxmlformats.org/drawingml/2006/main" w="9525">
+          <a:ln w="9525">
             <a:solidFill>
               <a:srgbClr val="80CBC4"/>
             </a:solidFill>
@@ -13453,43 +13453,43 @@
       <p:sp>
         <p:nvSpPr>
           <p:cNvPr id="32" name="">
-            <a:extLst xmlns:a="http://schemas.openxmlformats.org/drawingml/2006/main">
-              <a:ext uri="{FF2B5EF4-FFF2-40B4-BE49-F238E27FC236}">
-                <a16:creationId xmlns:a16="http://schemas.microsoft.com/office/drawing/2014/main" id="{DCB98483-F338-497B-AC6A-4F90BF1714E6}"/>
-              </a:ext>
-            </a:extLst>
-          </p:cNvPr>
-          <p:cNvSpPr>
-            <a:spLocks xmlns:a="http://schemas.openxmlformats.org/drawingml/2006/main" noGrp="1"/>
-          </p:cNvSpPr>
-          <p:nvPr/>
-        </p:nvSpPr>
-        <p:spPr>
-          <a:xfrm xmlns:a="http://schemas.openxmlformats.org/drawingml/2006/main">
+            <a:extLst>
+              <a:ext uri="{FF2B5EF4-FFF2-40B4-BE49-F238E27FC236}">
+                <ns2:creationId id="{DCB98483-F338-497B-AC6A-4F90BF1714E6}"/>
+              </a:ext>
+            </a:extLst>
+          </p:cNvPr>
+          <p:cNvSpPr>
+            <a:spLocks noGrp="1"/>
+          </p:cNvSpPr>
+          <p:nvPr/>
+        </p:nvSpPr>
+        <p:spPr>
+          <a:xfrm>
             <a:off x="7334250" y="4991100"/>
             <a:ext cx="895350" cy="171450"/>
           </a:xfrm>
-          <a:prstGeom xmlns:a="http://schemas.openxmlformats.org/drawingml/2006/main" prst="rect">
-            <a:avLst/>
-          </a:prstGeom>
-          <a:solidFill xmlns:a="http://schemas.openxmlformats.org/drawingml/2006/main">
+          <a:prstGeom prst="rect">
+            <a:avLst/>
+          </a:prstGeom>
+          <a:solidFill>
             <a:srgbClr val="000000">
               <a:alpha val="0"/>
             </a:srgbClr>
           </a:solidFill>
-          <a:ln xmlns:a="http://schemas.openxmlformats.org/drawingml/2006/main" w="0">
-            <a:solidFill>
-              <a:srgbClr val="000000">
-                <a:alpha val="0"/>
-              </a:srgbClr>
-            </a:solidFill>
-            <a:prstDash val="solid"/>
-          </a:ln>
-        </p:spPr>
-        <p:txBody>
-          <a:bodyPr xmlns:a="http://schemas.openxmlformats.org/drawingml/2006/main" lIns="0" tIns="0" rIns="0" bIns="0" anchor="t"/>
-          <a:lstStyle xmlns:a="http://schemas.openxmlformats.org/drawingml/2006/main"/>
-          <a:p xmlns:a="http://schemas.openxmlformats.org/drawingml/2006/main">
+          <a:ln w="0">
+            <a:solidFill>
+              <a:srgbClr val="000000">
+                <a:alpha val="0"/>
+              </a:srgbClr>
+            </a:solidFill>
+            <a:prstDash val="solid"/>
+          </a:ln>
+        </p:spPr>
+        <p:txBody>
+          <a:bodyPr lIns="0" tIns="0" rIns="0" bIns="0" anchor="t"/>
+          <a:lstStyle/>
+          <a:p>
             <a:pPr algn="ctr">
               <a:defRPr sz="825" b="1">
                 <a:solidFill>
@@ -13517,29 +13517,29 @@
       <p:sp>
         <p:nvSpPr>
           <p:cNvPr id="33" name="">
-            <a:extLst xmlns:a="http://schemas.openxmlformats.org/drawingml/2006/main">
-              <a:ext uri="{FF2B5EF4-FFF2-40B4-BE49-F238E27FC236}">
-                <a16:creationId xmlns:a16="http://schemas.microsoft.com/office/drawing/2014/main" id="{93C87242-1684-4CD4-82F3-964261477B9D}"/>
-              </a:ext>
-            </a:extLst>
-          </p:cNvPr>
-          <p:cNvSpPr>
-            <a:spLocks xmlns:a="http://schemas.openxmlformats.org/drawingml/2006/main" noGrp="1"/>
-          </p:cNvSpPr>
-          <p:nvPr/>
-        </p:nvSpPr>
-        <p:spPr>
-          <a:xfrm xmlns:a="http://schemas.openxmlformats.org/drawingml/2006/main">
+            <a:extLst>
+              <a:ext uri="{FF2B5EF4-FFF2-40B4-BE49-F238E27FC236}">
+                <ns2:creationId id="{93C87242-1684-4CD4-82F3-964261477B9D}"/>
+              </a:ext>
+            </a:extLst>
+          </p:cNvPr>
+          <p:cNvSpPr>
+            <a:spLocks noGrp="1"/>
+          </p:cNvSpPr>
+          <p:nvPr/>
+        </p:nvSpPr>
+        <p:spPr>
+          <a:xfrm>
             <a:off x="8343900" y="5067300"/>
             <a:ext cx="190500" cy="28575"/>
           </a:xfrm>
-          <a:prstGeom xmlns:a="http://schemas.openxmlformats.org/drawingml/2006/main" prst="rect">
-            <a:avLst/>
-          </a:prstGeom>
-          <a:solidFill xmlns:a="http://schemas.openxmlformats.org/drawingml/2006/main">
+          <a:prstGeom prst="rect">
+            <a:avLst/>
+          </a:prstGeom>
+          <a:solidFill>
             <a:srgbClr val="80CBC4"/>
           </a:solidFill>
-          <a:ln xmlns:a="http://schemas.openxmlformats.org/drawingml/2006/main" w="0">
+          <a:ln w="0">
             <a:solidFill>
               <a:srgbClr val="80CBC4"/>
             </a:solidFill>
@@ -13550,29 +13550,29 @@
       <p:sp>
         <p:nvSpPr>
           <p:cNvPr id="34" name="">
-            <a:extLst xmlns:a="http://schemas.openxmlformats.org/drawingml/2006/main">
-              <a:ext uri="{FF2B5EF4-FFF2-40B4-BE49-F238E27FC236}">
-                <a16:creationId xmlns:a16="http://schemas.microsoft.com/office/drawing/2014/main" id="{4D3D875D-3845-4488-8C56-FD28FAD50C18}"/>
-              </a:ext>
-            </a:extLst>
-          </p:cNvPr>
-          <p:cNvSpPr>
-            <a:spLocks xmlns:a="http://schemas.openxmlformats.org/drawingml/2006/main" noGrp="1"/>
-          </p:cNvSpPr>
-          <p:nvPr/>
-        </p:nvSpPr>
-        <p:spPr>
-          <a:xfrm xmlns:a="http://schemas.openxmlformats.org/drawingml/2006/main">
+            <a:extLst>
+              <a:ext uri="{FF2B5EF4-FFF2-40B4-BE49-F238E27FC236}">
+                <ns2:creationId id="{4D3D875D-3845-4488-8C56-FD28FAD50C18}"/>
+              </a:ext>
+            </a:extLst>
+          </p:cNvPr>
+          <p:cNvSpPr>
+            <a:spLocks noGrp="1"/>
+          </p:cNvSpPr>
+          <p:nvPr/>
+        </p:nvSpPr>
+        <p:spPr>
+          <a:xfrm>
             <a:off x="8572500" y="4876800"/>
             <a:ext cx="1047750" cy="400050"/>
           </a:xfrm>
-          <a:prstGeom xmlns:a="http://schemas.openxmlformats.org/drawingml/2006/main" prst="rect">
-            <a:avLst/>
-          </a:prstGeom>
-          <a:solidFill xmlns:a="http://schemas.openxmlformats.org/drawingml/2006/main">
+          <a:prstGeom prst="rect">
+            <a:avLst/>
+          </a:prstGeom>
+          <a:solidFill>
             <a:srgbClr val="10243A"/>
           </a:solidFill>
-          <a:ln xmlns:a="http://schemas.openxmlformats.org/drawingml/2006/main" w="9525">
+          <a:ln w="9525">
             <a:solidFill>
               <a:srgbClr val="80CBC4"/>
             </a:solidFill>
@@ -13583,43 +13583,43 @@
       <p:sp>
         <p:nvSpPr>
           <p:cNvPr id="35" name="">
-            <a:extLst xmlns:a="http://schemas.openxmlformats.org/drawingml/2006/main">
-              <a:ext uri="{FF2B5EF4-FFF2-40B4-BE49-F238E27FC236}">
-                <a16:creationId xmlns:a16="http://schemas.microsoft.com/office/drawing/2014/main" id="{2FA3408C-CEBA-430D-BD2E-29579EFFF8D3}"/>
-              </a:ext>
-            </a:extLst>
-          </p:cNvPr>
-          <p:cNvSpPr>
-            <a:spLocks xmlns:a="http://schemas.openxmlformats.org/drawingml/2006/main" noGrp="1"/>
-          </p:cNvSpPr>
-          <p:nvPr/>
-        </p:nvSpPr>
-        <p:spPr>
-          <a:xfrm xmlns:a="http://schemas.openxmlformats.org/drawingml/2006/main">
+            <a:extLst>
+              <a:ext uri="{FF2B5EF4-FFF2-40B4-BE49-F238E27FC236}">
+                <ns2:creationId id="{2FA3408C-CEBA-430D-BD2E-29579EFFF8D3}"/>
+              </a:ext>
+            </a:extLst>
+          </p:cNvPr>
+          <p:cNvSpPr>
+            <a:spLocks noGrp="1"/>
+          </p:cNvSpPr>
+          <p:nvPr/>
+        </p:nvSpPr>
+        <p:spPr>
+          <a:xfrm>
             <a:off x="8648700" y="4991100"/>
             <a:ext cx="895350" cy="171450"/>
           </a:xfrm>
-          <a:prstGeom xmlns:a="http://schemas.openxmlformats.org/drawingml/2006/main" prst="rect">
-            <a:avLst/>
-          </a:prstGeom>
-          <a:solidFill xmlns:a="http://schemas.openxmlformats.org/drawingml/2006/main">
+          <a:prstGeom prst="rect">
+            <a:avLst/>
+          </a:prstGeom>
+          <a:solidFill>
             <a:srgbClr val="000000">
               <a:alpha val="0"/>
             </a:srgbClr>
           </a:solidFill>
-          <a:ln xmlns:a="http://schemas.openxmlformats.org/drawingml/2006/main" w="0">
-            <a:solidFill>
-              <a:srgbClr val="000000">
-                <a:alpha val="0"/>
-              </a:srgbClr>
-            </a:solidFill>
-            <a:prstDash val="solid"/>
-          </a:ln>
-        </p:spPr>
-        <p:txBody>
-          <a:bodyPr xmlns:a="http://schemas.openxmlformats.org/drawingml/2006/main" lIns="0" tIns="0" rIns="0" bIns="0" anchor="t"/>
-          <a:lstStyle xmlns:a="http://schemas.openxmlformats.org/drawingml/2006/main"/>
-          <a:p xmlns:a="http://schemas.openxmlformats.org/drawingml/2006/main">
+          <a:ln w="0">
+            <a:solidFill>
+              <a:srgbClr val="000000">
+                <a:alpha val="0"/>
+              </a:srgbClr>
+            </a:solidFill>
+            <a:prstDash val="solid"/>
+          </a:ln>
+        </p:spPr>
+        <p:txBody>
+          <a:bodyPr lIns="0" tIns="0" rIns="0" bIns="0" anchor="t"/>
+          <a:lstStyle/>
+          <a:p>
             <a:pPr algn="ctr">
               <a:defRPr sz="825" b="1">
                 <a:solidFill>
@@ -13647,29 +13647,29 @@
       <p:sp>
         <p:nvSpPr>
           <p:cNvPr id="36" name="">
-            <a:extLst xmlns:a="http://schemas.openxmlformats.org/drawingml/2006/main">
-              <a:ext uri="{FF2B5EF4-FFF2-40B4-BE49-F238E27FC236}">
-                <a16:creationId xmlns:a16="http://schemas.microsoft.com/office/drawing/2014/main" id="{5E63E5C9-F773-4208-B40B-8FF32C5B5E9B}"/>
-              </a:ext>
-            </a:extLst>
-          </p:cNvPr>
-          <p:cNvSpPr>
-            <a:spLocks xmlns:a="http://schemas.openxmlformats.org/drawingml/2006/main" noGrp="1"/>
-          </p:cNvSpPr>
-          <p:nvPr/>
-        </p:nvSpPr>
-        <p:spPr>
-          <a:xfrm xmlns:a="http://schemas.openxmlformats.org/drawingml/2006/main">
+            <a:extLst>
+              <a:ext uri="{FF2B5EF4-FFF2-40B4-BE49-F238E27FC236}">
+                <ns2:creationId id="{5E63E5C9-F773-4208-B40B-8FF32C5B5E9B}"/>
+              </a:ext>
+            </a:extLst>
+          </p:cNvPr>
+          <p:cNvSpPr>
+            <a:spLocks noGrp="1"/>
+          </p:cNvSpPr>
+          <p:nvPr/>
+        </p:nvSpPr>
+        <p:spPr>
+          <a:xfrm>
             <a:off x="514350" y="6191250"/>
             <a:ext cx="1485900" cy="228600"/>
           </a:xfrm>
-          <a:prstGeom xmlns:a="http://schemas.openxmlformats.org/drawingml/2006/main" prst="rect">
-            <a:avLst/>
-          </a:prstGeom>
-          <a:solidFill xmlns:a="http://schemas.openxmlformats.org/drawingml/2006/main">
+          <a:prstGeom prst="rect">
+            <a:avLst/>
+          </a:prstGeom>
+          <a:solidFill>
             <a:srgbClr val="0D1B2E"/>
           </a:solidFill>
-          <a:ln xmlns:a="http://schemas.openxmlformats.org/drawingml/2006/main" w="9525">
+          <a:ln w="9525">
             <a:solidFill>
               <a:srgbClr val="24435F"/>
             </a:solidFill>
@@ -13680,43 +13680,43 @@
       <p:sp>
         <p:nvSpPr>
           <p:cNvPr id="37" name="">
-            <a:extLst xmlns:a="http://schemas.openxmlformats.org/drawingml/2006/main">
-              <a:ext uri="{FF2B5EF4-FFF2-40B4-BE49-F238E27FC236}">
-                <a16:creationId xmlns:a16="http://schemas.microsoft.com/office/drawing/2014/main" id="{1AE7A0E8-A977-4605-93DD-F0E8F7EE340D}"/>
-              </a:ext>
-            </a:extLst>
-          </p:cNvPr>
-          <p:cNvSpPr>
-            <a:spLocks xmlns:a="http://schemas.openxmlformats.org/drawingml/2006/main" noGrp="1"/>
-          </p:cNvSpPr>
-          <p:nvPr/>
-        </p:nvSpPr>
-        <p:spPr>
-          <a:xfrm xmlns:a="http://schemas.openxmlformats.org/drawingml/2006/main">
+            <a:extLst>
+              <a:ext uri="{FF2B5EF4-FFF2-40B4-BE49-F238E27FC236}">
+                <ns2:creationId id="{1AE7A0E8-A977-4605-93DD-F0E8F7EE340D}"/>
+              </a:ext>
+            </a:extLst>
+          </p:cNvPr>
+          <p:cNvSpPr>
+            <a:spLocks noGrp="1"/>
+          </p:cNvSpPr>
+          <p:nvPr/>
+        </p:nvSpPr>
+        <p:spPr>
+          <a:xfrm>
             <a:off x="590550" y="6238875"/>
             <a:ext cx="1333500" cy="133350"/>
           </a:xfrm>
-          <a:prstGeom xmlns:a="http://schemas.openxmlformats.org/drawingml/2006/main" prst="rect">
-            <a:avLst/>
-          </a:prstGeom>
-          <a:solidFill xmlns:a="http://schemas.openxmlformats.org/drawingml/2006/main">
+          <a:prstGeom prst="rect">
+            <a:avLst/>
+          </a:prstGeom>
+          <a:solidFill>
             <a:srgbClr val="000000">
               <a:alpha val="0"/>
             </a:srgbClr>
           </a:solidFill>
-          <a:ln xmlns:a="http://schemas.openxmlformats.org/drawingml/2006/main" w="0">
-            <a:solidFill>
-              <a:srgbClr val="000000">
-                <a:alpha val="0"/>
-              </a:srgbClr>
-            </a:solidFill>
-            <a:prstDash val="solid"/>
-          </a:ln>
-        </p:spPr>
-        <p:txBody>
-          <a:bodyPr xmlns:a="http://schemas.openxmlformats.org/drawingml/2006/main" lIns="0" tIns="0" rIns="0" bIns="0" anchor="t"/>
-          <a:lstStyle xmlns:a="http://schemas.openxmlformats.org/drawingml/2006/main"/>
-          <a:p xmlns:a="http://schemas.openxmlformats.org/drawingml/2006/main">
+          <a:ln w="0">
+            <a:solidFill>
+              <a:srgbClr val="000000">
+                <a:alpha val="0"/>
+              </a:srgbClr>
+            </a:solidFill>
+            <a:prstDash val="solid"/>
+          </a:ln>
+        </p:spPr>
+        <p:txBody>
+          <a:bodyPr lIns="0" tIns="0" rIns="0" bIns="0" anchor="t"/>
+          <a:lstStyle/>
+          <a:p>
             <a:pPr algn="ctr">
               <a:defRPr sz="675" b="0">
                 <a:solidFill>
@@ -13744,29 +13744,29 @@
       <p:sp>
         <p:nvSpPr>
           <p:cNvPr id="38" name="">
-            <a:extLst xmlns:a="http://schemas.openxmlformats.org/drawingml/2006/main">
-              <a:ext uri="{FF2B5EF4-FFF2-40B4-BE49-F238E27FC236}">
-                <a16:creationId xmlns:a16="http://schemas.microsoft.com/office/drawing/2014/main" id="{AFC1C563-769E-45AA-8EE6-320CD5F9DFBB}"/>
-              </a:ext>
-            </a:extLst>
-          </p:cNvPr>
-          <p:cNvSpPr>
-            <a:spLocks xmlns:a="http://schemas.openxmlformats.org/drawingml/2006/main" noGrp="1"/>
-          </p:cNvSpPr>
-          <p:nvPr/>
-        </p:nvSpPr>
-        <p:spPr>
-          <a:xfrm xmlns:a="http://schemas.openxmlformats.org/drawingml/2006/main">
+            <a:extLst>
+              <a:ext uri="{FF2B5EF4-FFF2-40B4-BE49-F238E27FC236}">
+                <ns2:creationId id="{AFC1C563-769E-45AA-8EE6-320CD5F9DFBB}"/>
+              </a:ext>
+            </a:extLst>
+          </p:cNvPr>
+          <p:cNvSpPr>
+            <a:spLocks noGrp="1"/>
+          </p:cNvSpPr>
+          <p:nvPr/>
+        </p:nvSpPr>
+        <p:spPr>
+          <a:xfrm>
             <a:off x="2133600" y="6191250"/>
             <a:ext cx="1485900" cy="228600"/>
           </a:xfrm>
-          <a:prstGeom xmlns:a="http://schemas.openxmlformats.org/drawingml/2006/main" prst="rect">
-            <a:avLst/>
-          </a:prstGeom>
-          <a:solidFill xmlns:a="http://schemas.openxmlformats.org/drawingml/2006/main">
+          <a:prstGeom prst="rect">
+            <a:avLst/>
+          </a:prstGeom>
+          <a:solidFill>
             <a:srgbClr val="0D1B2E"/>
           </a:solidFill>
-          <a:ln xmlns:a="http://schemas.openxmlformats.org/drawingml/2006/main" w="9525">
+          <a:ln w="9525">
             <a:solidFill>
               <a:srgbClr val="24435F"/>
             </a:solidFill>
@@ -13777,43 +13777,43 @@
       <p:sp>
         <p:nvSpPr>
           <p:cNvPr id="39" name="">
-            <a:extLst xmlns:a="http://schemas.openxmlformats.org/drawingml/2006/main">
-              <a:ext uri="{FF2B5EF4-FFF2-40B4-BE49-F238E27FC236}">
-                <a16:creationId xmlns:a16="http://schemas.microsoft.com/office/drawing/2014/main" id="{AC707F3D-6FC2-4D0A-9149-C3376493DA3D}"/>
-              </a:ext>
-            </a:extLst>
-          </p:cNvPr>
-          <p:cNvSpPr>
-            <a:spLocks xmlns:a="http://schemas.openxmlformats.org/drawingml/2006/main" noGrp="1"/>
-          </p:cNvSpPr>
-          <p:nvPr/>
-        </p:nvSpPr>
-        <p:spPr>
-          <a:xfrm xmlns:a="http://schemas.openxmlformats.org/drawingml/2006/main">
+            <a:extLst>
+              <a:ext uri="{FF2B5EF4-FFF2-40B4-BE49-F238E27FC236}">
+                <ns2:creationId id="{AC707F3D-6FC2-4D0A-9149-C3376493DA3D}"/>
+              </a:ext>
+            </a:extLst>
+          </p:cNvPr>
+          <p:cNvSpPr>
+            <a:spLocks noGrp="1"/>
+          </p:cNvSpPr>
+          <p:nvPr/>
+        </p:nvSpPr>
+        <p:spPr>
+          <a:xfrm>
             <a:off x="2209800" y="6238875"/>
             <a:ext cx="1333500" cy="133350"/>
           </a:xfrm>
-          <a:prstGeom xmlns:a="http://schemas.openxmlformats.org/drawingml/2006/main" prst="rect">
-            <a:avLst/>
-          </a:prstGeom>
-          <a:solidFill xmlns:a="http://schemas.openxmlformats.org/drawingml/2006/main">
+          <a:prstGeom prst="rect">
+            <a:avLst/>
+          </a:prstGeom>
+          <a:solidFill>
             <a:srgbClr val="000000">
               <a:alpha val="0"/>
             </a:srgbClr>
           </a:solidFill>
-          <a:ln xmlns:a="http://schemas.openxmlformats.org/drawingml/2006/main" w="0">
-            <a:solidFill>
-              <a:srgbClr val="000000">
-                <a:alpha val="0"/>
-              </a:srgbClr>
-            </a:solidFill>
-            <a:prstDash val="solid"/>
-          </a:ln>
-        </p:spPr>
-        <p:txBody>
-          <a:bodyPr xmlns:a="http://schemas.openxmlformats.org/drawingml/2006/main" lIns="0" tIns="0" rIns="0" bIns="0" anchor="t"/>
-          <a:lstStyle xmlns:a="http://schemas.openxmlformats.org/drawingml/2006/main"/>
-          <a:p xmlns:a="http://schemas.openxmlformats.org/drawingml/2006/main">
+          <a:ln w="0">
+            <a:solidFill>
+              <a:srgbClr val="000000">
+                <a:alpha val="0"/>
+              </a:srgbClr>
+            </a:solidFill>
+            <a:prstDash val="solid"/>
+          </a:ln>
+        </p:spPr>
+        <p:txBody>
+          <a:bodyPr lIns="0" tIns="0" rIns="0" bIns="0" anchor="t"/>
+          <a:lstStyle/>
+          <a:p>
             <a:pPr algn="ctr">
               <a:defRPr sz="675" b="0">
                 <a:solidFill>
@@ -13841,29 +13841,29 @@
       <p:sp>
         <p:nvSpPr>
           <p:cNvPr id="40" name="">
-            <a:extLst xmlns:a="http://schemas.openxmlformats.org/drawingml/2006/main">
-              <a:ext uri="{FF2B5EF4-FFF2-40B4-BE49-F238E27FC236}">
-                <a16:creationId xmlns:a16="http://schemas.microsoft.com/office/drawing/2014/main" id="{C8EA6283-D2C4-4E77-98E4-AB66553667C6}"/>
-              </a:ext>
-            </a:extLst>
-          </p:cNvPr>
-          <p:cNvSpPr>
-            <a:spLocks xmlns:a="http://schemas.openxmlformats.org/drawingml/2006/main" noGrp="1"/>
-          </p:cNvSpPr>
-          <p:nvPr/>
-        </p:nvSpPr>
-        <p:spPr>
-          <a:xfrm xmlns:a="http://schemas.openxmlformats.org/drawingml/2006/main">
+            <a:extLst>
+              <a:ext uri="{FF2B5EF4-FFF2-40B4-BE49-F238E27FC236}">
+                <ns2:creationId id="{C8EA6283-D2C4-4E77-98E4-AB66553667C6}"/>
+              </a:ext>
+            </a:extLst>
+          </p:cNvPr>
+          <p:cNvSpPr>
+            <a:spLocks noGrp="1"/>
+          </p:cNvSpPr>
+          <p:nvPr/>
+        </p:nvSpPr>
+        <p:spPr>
+          <a:xfrm>
             <a:off x="3752850" y="6191250"/>
             <a:ext cx="1485900" cy="228600"/>
           </a:xfrm>
-          <a:prstGeom xmlns:a="http://schemas.openxmlformats.org/drawingml/2006/main" prst="rect">
-            <a:avLst/>
-          </a:prstGeom>
-          <a:solidFill xmlns:a="http://schemas.openxmlformats.org/drawingml/2006/main">
+          <a:prstGeom prst="rect">
+            <a:avLst/>
+          </a:prstGeom>
+          <a:solidFill>
             <a:srgbClr val="4FC3F7"/>
           </a:solidFill>
-          <a:ln xmlns:a="http://schemas.openxmlformats.org/drawingml/2006/main" w="9525">
+          <a:ln w="9525">
             <a:solidFill>
               <a:srgbClr val="4FC3F7"/>
             </a:solidFill>
@@ -13874,43 +13874,43 @@
       <p:sp>
         <p:nvSpPr>
           <p:cNvPr id="41" name="">
-            <a:extLst xmlns:a="http://schemas.openxmlformats.org/drawingml/2006/main">
-              <a:ext uri="{FF2B5EF4-FFF2-40B4-BE49-F238E27FC236}">
-                <a16:creationId xmlns:a16="http://schemas.microsoft.com/office/drawing/2014/main" id="{C38F9D20-5473-4CD8-BF4B-3A018F398A38}"/>
-              </a:ext>
-            </a:extLst>
-          </p:cNvPr>
-          <p:cNvSpPr>
-            <a:spLocks xmlns:a="http://schemas.openxmlformats.org/drawingml/2006/main" noGrp="1"/>
-          </p:cNvSpPr>
-          <p:nvPr/>
-        </p:nvSpPr>
-        <p:spPr>
-          <a:xfrm xmlns:a="http://schemas.openxmlformats.org/drawingml/2006/main">
+            <a:extLst>
+              <a:ext uri="{FF2B5EF4-FFF2-40B4-BE49-F238E27FC236}">
+                <ns2:creationId id="{C38F9D20-5473-4CD8-BF4B-3A018F398A38}"/>
+              </a:ext>
+            </a:extLst>
+          </p:cNvPr>
+          <p:cNvSpPr>
+            <a:spLocks noGrp="1"/>
+          </p:cNvSpPr>
+          <p:nvPr/>
+        </p:nvSpPr>
+        <p:spPr>
+          <a:xfrm>
             <a:off x="3829050" y="6238875"/>
             <a:ext cx="1333500" cy="133350"/>
           </a:xfrm>
-          <a:prstGeom xmlns:a="http://schemas.openxmlformats.org/drawingml/2006/main" prst="rect">
-            <a:avLst/>
-          </a:prstGeom>
-          <a:solidFill xmlns:a="http://schemas.openxmlformats.org/drawingml/2006/main">
+          <a:prstGeom prst="rect">
+            <a:avLst/>
+          </a:prstGeom>
+          <a:solidFill>
             <a:srgbClr val="000000">
               <a:alpha val="0"/>
             </a:srgbClr>
           </a:solidFill>
-          <a:ln xmlns:a="http://schemas.openxmlformats.org/drawingml/2006/main" w="0">
-            <a:solidFill>
-              <a:srgbClr val="000000">
-                <a:alpha val="0"/>
-              </a:srgbClr>
-            </a:solidFill>
-            <a:prstDash val="solid"/>
-          </a:ln>
-        </p:spPr>
-        <p:txBody>
-          <a:bodyPr xmlns:a="http://schemas.openxmlformats.org/drawingml/2006/main" lIns="0" tIns="0" rIns="0" bIns="0" anchor="t"/>
-          <a:lstStyle xmlns:a="http://schemas.openxmlformats.org/drawingml/2006/main"/>
-          <a:p xmlns:a="http://schemas.openxmlformats.org/drawingml/2006/main">
+          <a:ln w="0">
+            <a:solidFill>
+              <a:srgbClr val="000000">
+                <a:alpha val="0"/>
+              </a:srgbClr>
+            </a:solidFill>
+            <a:prstDash val="solid"/>
+          </a:ln>
+        </p:spPr>
+        <p:txBody>
+          <a:bodyPr lIns="0" tIns="0" rIns="0" bIns="0" anchor="t"/>
+          <a:lstStyle/>
+          <a:p>
             <a:pPr algn="ctr">
               <a:defRPr sz="675" b="1">
                 <a:solidFill>
@@ -13938,29 +13938,29 @@
       <p:sp>
         <p:nvSpPr>
           <p:cNvPr id="42" name="">
-            <a:extLst xmlns:a="http://schemas.openxmlformats.org/drawingml/2006/main">
-              <a:ext uri="{FF2B5EF4-FFF2-40B4-BE49-F238E27FC236}">
-                <a16:creationId xmlns:a16="http://schemas.microsoft.com/office/drawing/2014/main" id="{C770F51A-D1D8-4B51-B604-66D8FA5C75E1}"/>
-              </a:ext>
-            </a:extLst>
-          </p:cNvPr>
-          <p:cNvSpPr>
-            <a:spLocks xmlns:a="http://schemas.openxmlformats.org/drawingml/2006/main" noGrp="1"/>
-          </p:cNvSpPr>
-          <p:nvPr/>
-        </p:nvSpPr>
-        <p:spPr>
-          <a:xfrm xmlns:a="http://schemas.openxmlformats.org/drawingml/2006/main">
+            <a:extLst>
+              <a:ext uri="{FF2B5EF4-FFF2-40B4-BE49-F238E27FC236}">
+                <ns2:creationId id="{C770F51A-D1D8-4B51-B604-66D8FA5C75E1}"/>
+              </a:ext>
+            </a:extLst>
+          </p:cNvPr>
+          <p:cNvSpPr>
+            <a:spLocks noGrp="1"/>
+          </p:cNvSpPr>
+          <p:nvPr/>
+        </p:nvSpPr>
+        <p:spPr>
+          <a:xfrm>
             <a:off x="5372100" y="6191250"/>
             <a:ext cx="1485900" cy="228600"/>
           </a:xfrm>
-          <a:prstGeom xmlns:a="http://schemas.openxmlformats.org/drawingml/2006/main" prst="rect">
-            <a:avLst/>
-          </a:prstGeom>
-          <a:solidFill xmlns:a="http://schemas.openxmlformats.org/drawingml/2006/main">
+          <a:prstGeom prst="rect">
+            <a:avLst/>
+          </a:prstGeom>
+          <a:solidFill>
             <a:srgbClr val="0D1B2E"/>
           </a:solidFill>
-          <a:ln xmlns:a="http://schemas.openxmlformats.org/drawingml/2006/main" w="9525">
+          <a:ln w="9525">
             <a:solidFill>
               <a:srgbClr val="24435F"/>
             </a:solidFill>
@@ -13971,43 +13971,43 @@
       <p:sp>
         <p:nvSpPr>
           <p:cNvPr id="43" name="">
-            <a:extLst xmlns:a="http://schemas.openxmlformats.org/drawingml/2006/main">
-              <a:ext uri="{FF2B5EF4-FFF2-40B4-BE49-F238E27FC236}">
-                <a16:creationId xmlns:a16="http://schemas.microsoft.com/office/drawing/2014/main" id="{FBD91072-396D-4AF9-A44A-A0431EB67A0F}"/>
-              </a:ext>
-            </a:extLst>
-          </p:cNvPr>
-          <p:cNvSpPr>
-            <a:spLocks xmlns:a="http://schemas.openxmlformats.org/drawingml/2006/main" noGrp="1"/>
-          </p:cNvSpPr>
-          <p:nvPr/>
-        </p:nvSpPr>
-        <p:spPr>
-          <a:xfrm xmlns:a="http://schemas.openxmlformats.org/drawingml/2006/main">
+            <a:extLst>
+              <a:ext uri="{FF2B5EF4-FFF2-40B4-BE49-F238E27FC236}">
+                <ns2:creationId id="{FBD91072-396D-4AF9-A44A-A0431EB67A0F}"/>
+              </a:ext>
+            </a:extLst>
+          </p:cNvPr>
+          <p:cNvSpPr>
+            <a:spLocks noGrp="1"/>
+          </p:cNvSpPr>
+          <p:nvPr/>
+        </p:nvSpPr>
+        <p:spPr>
+          <a:xfrm>
             <a:off x="5448300" y="6238875"/>
             <a:ext cx="1333500" cy="133350"/>
           </a:xfrm>
-          <a:prstGeom xmlns:a="http://schemas.openxmlformats.org/drawingml/2006/main" prst="rect">
-            <a:avLst/>
-          </a:prstGeom>
-          <a:solidFill xmlns:a="http://schemas.openxmlformats.org/drawingml/2006/main">
+          <a:prstGeom prst="rect">
+            <a:avLst/>
+          </a:prstGeom>
+          <a:solidFill>
             <a:srgbClr val="000000">
               <a:alpha val="0"/>
             </a:srgbClr>
           </a:solidFill>
-          <a:ln xmlns:a="http://schemas.openxmlformats.org/drawingml/2006/main" w="0">
-            <a:solidFill>
-              <a:srgbClr val="000000">
-                <a:alpha val="0"/>
-              </a:srgbClr>
-            </a:solidFill>
-            <a:prstDash val="solid"/>
-          </a:ln>
-        </p:spPr>
-        <p:txBody>
-          <a:bodyPr xmlns:a="http://schemas.openxmlformats.org/drawingml/2006/main" lIns="0" tIns="0" rIns="0" bIns="0" anchor="t"/>
-          <a:lstStyle xmlns:a="http://schemas.openxmlformats.org/drawingml/2006/main"/>
-          <a:p xmlns:a="http://schemas.openxmlformats.org/drawingml/2006/main">
+          <a:ln w="0">
+            <a:solidFill>
+              <a:srgbClr val="000000">
+                <a:alpha val="0"/>
+              </a:srgbClr>
+            </a:solidFill>
+            <a:prstDash val="solid"/>
+          </a:ln>
+        </p:spPr>
+        <p:txBody>
+          <a:bodyPr lIns="0" tIns="0" rIns="0" bIns="0" anchor="t"/>
+          <a:lstStyle/>
+          <a:p>
             <a:pPr algn="ctr">
               <a:defRPr sz="675" b="0">
                 <a:solidFill>
@@ -14035,29 +14035,29 @@
       <p:sp>
         <p:nvSpPr>
           <p:cNvPr id="44" name="">
-            <a:extLst xmlns:a="http://schemas.openxmlformats.org/drawingml/2006/main">
-              <a:ext uri="{FF2B5EF4-FFF2-40B4-BE49-F238E27FC236}">
-                <a16:creationId xmlns:a16="http://schemas.microsoft.com/office/drawing/2014/main" id="{2CB15D2C-2EC6-4B6E-BBAA-8A7B1C881595}"/>
-              </a:ext>
-            </a:extLst>
-          </p:cNvPr>
-          <p:cNvSpPr>
-            <a:spLocks xmlns:a="http://schemas.openxmlformats.org/drawingml/2006/main" noGrp="1"/>
-          </p:cNvSpPr>
-          <p:nvPr/>
-        </p:nvSpPr>
-        <p:spPr>
-          <a:xfrm xmlns:a="http://schemas.openxmlformats.org/drawingml/2006/main">
+            <a:extLst>
+              <a:ext uri="{FF2B5EF4-FFF2-40B4-BE49-F238E27FC236}">
+                <ns2:creationId id="{2CB15D2C-2EC6-4B6E-BBAA-8A7B1C881595}"/>
+              </a:ext>
+            </a:extLst>
+          </p:cNvPr>
+          <p:cNvSpPr>
+            <a:spLocks noGrp="1"/>
+          </p:cNvSpPr>
+          <p:nvPr/>
+        </p:nvSpPr>
+        <p:spPr>
+          <a:xfrm>
             <a:off x="6991350" y="6191250"/>
             <a:ext cx="1485900" cy="228600"/>
           </a:xfrm>
-          <a:prstGeom xmlns:a="http://schemas.openxmlformats.org/drawingml/2006/main" prst="rect">
-            <a:avLst/>
-          </a:prstGeom>
-          <a:solidFill xmlns:a="http://schemas.openxmlformats.org/drawingml/2006/main">
+          <a:prstGeom prst="rect">
+            <a:avLst/>
+          </a:prstGeom>
+          <a:solidFill>
             <a:srgbClr val="0D1B2E"/>
           </a:solidFill>
-          <a:ln xmlns:a="http://schemas.openxmlformats.org/drawingml/2006/main" w="9525">
+          <a:ln w="9525">
             <a:solidFill>
               <a:srgbClr val="24435F"/>
             </a:solidFill>
@@ -14068,43 +14068,43 @@
       <p:sp>
         <p:nvSpPr>
           <p:cNvPr id="45" name="">
-            <a:extLst xmlns:a="http://schemas.openxmlformats.org/drawingml/2006/main">
-              <a:ext uri="{FF2B5EF4-FFF2-40B4-BE49-F238E27FC236}">
-                <a16:creationId xmlns:a16="http://schemas.microsoft.com/office/drawing/2014/main" id="{C4A3B361-8BF1-477D-BE3F-7FFF3094CAA1}"/>
-              </a:ext>
-            </a:extLst>
-          </p:cNvPr>
-          <p:cNvSpPr>
-            <a:spLocks xmlns:a="http://schemas.openxmlformats.org/drawingml/2006/main" noGrp="1"/>
-          </p:cNvSpPr>
-          <p:nvPr/>
-        </p:nvSpPr>
-        <p:spPr>
-          <a:xfrm xmlns:a="http://schemas.openxmlformats.org/drawingml/2006/main">
+            <a:extLst>
+              <a:ext uri="{FF2B5EF4-FFF2-40B4-BE49-F238E27FC236}">
+                <ns2:creationId id="{C4A3B361-8BF1-477D-BE3F-7FFF3094CAA1}"/>
+              </a:ext>
+            </a:extLst>
+          </p:cNvPr>
+          <p:cNvSpPr>
+            <a:spLocks noGrp="1"/>
+          </p:cNvSpPr>
+          <p:nvPr/>
+        </p:nvSpPr>
+        <p:spPr>
+          <a:xfrm>
             <a:off x="7067550" y="6238875"/>
             <a:ext cx="1333500" cy="133350"/>
           </a:xfrm>
-          <a:prstGeom xmlns:a="http://schemas.openxmlformats.org/drawingml/2006/main" prst="rect">
-            <a:avLst/>
-          </a:prstGeom>
-          <a:solidFill xmlns:a="http://schemas.openxmlformats.org/drawingml/2006/main">
+          <a:prstGeom prst="rect">
+            <a:avLst/>
+          </a:prstGeom>
+          <a:solidFill>
             <a:srgbClr val="000000">
               <a:alpha val="0"/>
             </a:srgbClr>
           </a:solidFill>
-          <a:ln xmlns:a="http://schemas.openxmlformats.org/drawingml/2006/main" w="0">
-            <a:solidFill>
-              <a:srgbClr val="000000">
-                <a:alpha val="0"/>
-              </a:srgbClr>
-            </a:solidFill>
-            <a:prstDash val="solid"/>
-          </a:ln>
-        </p:spPr>
-        <p:txBody>
-          <a:bodyPr xmlns:a="http://schemas.openxmlformats.org/drawingml/2006/main" lIns="0" tIns="0" rIns="0" bIns="0" anchor="t"/>
-          <a:lstStyle xmlns:a="http://schemas.openxmlformats.org/drawingml/2006/main"/>
-          <a:p xmlns:a="http://schemas.openxmlformats.org/drawingml/2006/main">
+          <a:ln w="0">
+            <a:solidFill>
+              <a:srgbClr val="000000">
+                <a:alpha val="0"/>
+              </a:srgbClr>
+            </a:solidFill>
+            <a:prstDash val="solid"/>
+          </a:ln>
+        </p:spPr>
+        <p:txBody>
+          <a:bodyPr lIns="0" tIns="0" rIns="0" bIns="0" anchor="t"/>
+          <a:lstStyle/>
+          <a:p>
             <a:pPr algn="ctr">
               <a:defRPr sz="675" b="0">
                 <a:solidFill>
@@ -14132,43 +14132,43 @@
       <p:sp>
         <p:nvSpPr>
           <p:cNvPr id="46" name="">
-            <a:extLst xmlns:a="http://schemas.openxmlformats.org/drawingml/2006/main">
-              <a:ext uri="{FF2B5EF4-FFF2-40B4-BE49-F238E27FC236}">
-                <a16:creationId xmlns:a16="http://schemas.microsoft.com/office/drawing/2014/main" id="{6C7CD387-98B3-461A-8E4F-344B9EEA6DA1}"/>
-              </a:ext>
-            </a:extLst>
-          </p:cNvPr>
-          <p:cNvSpPr>
-            <a:spLocks xmlns:a="http://schemas.openxmlformats.org/drawingml/2006/main" noGrp="1"/>
-          </p:cNvSpPr>
-          <p:nvPr/>
-        </p:nvSpPr>
-        <p:spPr>
-          <a:xfrm xmlns:a="http://schemas.openxmlformats.org/drawingml/2006/main">
+            <a:extLst>
+              <a:ext uri="{FF2B5EF4-FFF2-40B4-BE49-F238E27FC236}">
+                <ns2:creationId id="{6C7CD387-98B3-461A-8E4F-344B9EEA6DA1}"/>
+              </a:ext>
+            </a:extLst>
+          </p:cNvPr>
+          <p:cNvSpPr>
+            <a:spLocks noGrp="1"/>
+          </p:cNvSpPr>
+          <p:nvPr/>
+        </p:nvSpPr>
+        <p:spPr>
+          <a:xfrm>
             <a:off x="11410950" y="6457950"/>
             <a:ext cx="381000" cy="209550"/>
           </a:xfrm>
-          <a:prstGeom xmlns:a="http://schemas.openxmlformats.org/drawingml/2006/main" prst="rect">
-            <a:avLst/>
-          </a:prstGeom>
-          <a:solidFill xmlns:a="http://schemas.openxmlformats.org/drawingml/2006/main">
+          <a:prstGeom prst="rect">
+            <a:avLst/>
+          </a:prstGeom>
+          <a:solidFill>
             <a:srgbClr val="000000">
               <a:alpha val="0"/>
             </a:srgbClr>
           </a:solidFill>
-          <a:ln xmlns:a="http://schemas.openxmlformats.org/drawingml/2006/main" w="0">
-            <a:solidFill>
-              <a:srgbClr val="000000">
-                <a:alpha val="0"/>
-              </a:srgbClr>
-            </a:solidFill>
-            <a:prstDash val="solid"/>
-          </a:ln>
-        </p:spPr>
-        <p:txBody>
-          <a:bodyPr xmlns:a="http://schemas.openxmlformats.org/drawingml/2006/main" lIns="0" tIns="0" rIns="0" bIns="0" anchor="t"/>
-          <a:lstStyle xmlns:a="http://schemas.openxmlformats.org/drawingml/2006/main"/>
-          <a:p xmlns:a="http://schemas.openxmlformats.org/drawingml/2006/main">
+          <a:ln w="0">
+            <a:solidFill>
+              <a:srgbClr val="000000">
+                <a:alpha val="0"/>
+              </a:srgbClr>
+            </a:solidFill>
+            <a:prstDash val="solid"/>
+          </a:ln>
+        </p:spPr>
+        <p:txBody>
+          <a:bodyPr lIns="0" tIns="0" rIns="0" bIns="0" anchor="t"/>
+          <a:lstStyle/>
+          <a:p>
             <a:pPr algn="r">
               <a:defRPr sz="900" b="0">
                 <a:solidFill>
@@ -14196,7 +14196,7 @@
     </p:spTree>
     <p:extLst>
       <p:ext uri="{BB962C8B-B14F-4D97-AF65-F5344CB8AC3E}">
-        <p14:creationId xmlns:p14="http://schemas.microsoft.com/office/powerpoint/2010/main" val="1644951478"/>
+        <ns4:creationId val="1644951478"/>
       </p:ext>
     </p:extLst>
   </p:cSld>

</xml_diff>